<commit_message>
feat: switch to local multi-engine conversion pipeline
</commit_message>
<xml_diff>
--- a/test-documents/powerpoint/pptx/powerpoint_with_image.pptx
+++ b/test-documents/powerpoint/pptx/powerpoint_with_image.pptx
@@ -5,15 +5,15 @@
     <p:sldMasterId id="2147483648" r:id="rId1"/>
   </p:sldMasterIdLst>
   <p:sldIdLst>
-    <p:sldId id="256" r:id="rId2"/>
+    <p:sldId id="256" r:id="rId7"/>
   </p:sldIdLst>
-  <p:sldSz cx="12192000" cy="6858000"/>
+  <p:sldSz cx="9144000" cy="6858000" type="screen4x3"/>
   <p:notesSz cx="6858000" cy="9144000"/>
   <p:defaultTextStyle>
     <a:defPPr>
       <a:defRPr lang="en-US"/>
     </a:defPPr>
-    <a:lvl1pPr marL="0" algn="l" defTabSz="914400" rtl="0" eaLnBrk="1" latinLnBrk="0" hangingPunct="1">
+    <a:lvl1pPr marL="0" algn="l" defTabSz="457200" rtl="0" eaLnBrk="1" latinLnBrk="0" hangingPunct="1">
       <a:defRPr sz="1800" kern="1200">
         <a:solidFill>
           <a:schemeClr val="tx1"/>
@@ -23,7 +23,7 @@
         <a:cs typeface="+mn-cs"/>
       </a:defRPr>
     </a:lvl1pPr>
-    <a:lvl2pPr marL="457200" algn="l" defTabSz="914400" rtl="0" eaLnBrk="1" latinLnBrk="0" hangingPunct="1">
+    <a:lvl2pPr marL="457200" algn="l" defTabSz="457200" rtl="0" eaLnBrk="1" latinLnBrk="0" hangingPunct="1">
       <a:defRPr sz="1800" kern="1200">
         <a:solidFill>
           <a:schemeClr val="tx1"/>
@@ -33,7 +33,7 @@
         <a:cs typeface="+mn-cs"/>
       </a:defRPr>
     </a:lvl2pPr>
-    <a:lvl3pPr marL="914400" algn="l" defTabSz="914400" rtl="0" eaLnBrk="1" latinLnBrk="0" hangingPunct="1">
+    <a:lvl3pPr marL="914400" algn="l" defTabSz="457200" rtl="0" eaLnBrk="1" latinLnBrk="0" hangingPunct="1">
       <a:defRPr sz="1800" kern="1200">
         <a:solidFill>
           <a:schemeClr val="tx1"/>
@@ -43,7 +43,7 @@
         <a:cs typeface="+mn-cs"/>
       </a:defRPr>
     </a:lvl3pPr>
-    <a:lvl4pPr marL="1371600" algn="l" defTabSz="914400" rtl="0" eaLnBrk="1" latinLnBrk="0" hangingPunct="1">
+    <a:lvl4pPr marL="1371600" algn="l" defTabSz="457200" rtl="0" eaLnBrk="1" latinLnBrk="0" hangingPunct="1">
       <a:defRPr sz="1800" kern="1200">
         <a:solidFill>
           <a:schemeClr val="tx1"/>
@@ -53,7 +53,7 @@
         <a:cs typeface="+mn-cs"/>
       </a:defRPr>
     </a:lvl4pPr>
-    <a:lvl5pPr marL="1828800" algn="l" defTabSz="914400" rtl="0" eaLnBrk="1" latinLnBrk="0" hangingPunct="1">
+    <a:lvl5pPr marL="1828800" algn="l" defTabSz="457200" rtl="0" eaLnBrk="1" latinLnBrk="0" hangingPunct="1">
       <a:defRPr sz="1800" kern="1200">
         <a:solidFill>
           <a:schemeClr val="tx1"/>
@@ -63,7 +63,7 @@
         <a:cs typeface="+mn-cs"/>
       </a:defRPr>
     </a:lvl5pPr>
-    <a:lvl6pPr marL="2286000" algn="l" defTabSz="914400" rtl="0" eaLnBrk="1" latinLnBrk="0" hangingPunct="1">
+    <a:lvl6pPr marL="2286000" algn="l" defTabSz="457200" rtl="0" eaLnBrk="1" latinLnBrk="0" hangingPunct="1">
       <a:defRPr sz="1800" kern="1200">
         <a:solidFill>
           <a:schemeClr val="tx1"/>
@@ -73,7 +73,7 @@
         <a:cs typeface="+mn-cs"/>
       </a:defRPr>
     </a:lvl6pPr>
-    <a:lvl7pPr marL="2743200" algn="l" defTabSz="914400" rtl="0" eaLnBrk="1" latinLnBrk="0" hangingPunct="1">
+    <a:lvl7pPr marL="2743200" algn="l" defTabSz="457200" rtl="0" eaLnBrk="1" latinLnBrk="0" hangingPunct="1">
       <a:defRPr sz="1800" kern="1200">
         <a:solidFill>
           <a:schemeClr val="tx1"/>
@@ -83,7 +83,7 @@
         <a:cs typeface="+mn-cs"/>
       </a:defRPr>
     </a:lvl7pPr>
-    <a:lvl8pPr marL="3200400" algn="l" defTabSz="914400" rtl="0" eaLnBrk="1" latinLnBrk="0" hangingPunct="1">
+    <a:lvl8pPr marL="3200400" algn="l" defTabSz="457200" rtl="0" eaLnBrk="1" latinLnBrk="0" hangingPunct="1">
       <a:defRPr sz="1800" kern="1200">
         <a:solidFill>
           <a:schemeClr val="tx1"/>
@@ -93,7 +93,7 @@
         <a:cs typeface="+mn-cs"/>
       </a:defRPr>
     </a:lvl8pPr>
-    <a:lvl9pPr marL="3657600" algn="l" defTabSz="914400" rtl="0" eaLnBrk="1" latinLnBrk="0" hangingPunct="1">
+    <a:lvl9pPr marL="3657600" algn="l" defTabSz="457200" rtl="0" eaLnBrk="1" latinLnBrk="0" hangingPunct="1">
       <a:defRPr sz="1800" kern="1200">
         <a:solidFill>
           <a:schemeClr val="tx1"/>
@@ -104,12 +104,427 @@
       </a:defRPr>
     </a:lvl9pPr>
   </p:defaultTextStyle>
-  <p:extLst>
-    <p:ext uri="{EFAFB233-063F-42B5-8137-9DF3F51BA10A}">
-      <p15:sldGuideLst xmlns:p15="http://schemas.microsoft.com/office/powerpoint/2012/main"/>
-    </p:ext>
-  </p:extLst>
 </p:presentation>
+</file>
+
+<file path=ppt/notesMasters/notesMaster1.xml><?xml version="1.0" encoding="utf-8"?>
+<p:notesMaster xmlns:a="http://schemas.openxmlformats.org/drawingml/2006/main" xmlns:p="http://schemas.openxmlformats.org/presentationml/2006/main" xmlns:r="http://schemas.openxmlformats.org/officeDocument/2006/relationships">
+  <p:cSld>
+    <p:bg>
+      <p:bgRef idx="1001">
+        <a:schemeClr val="bg1"/>
+      </p:bgRef>
+    </p:bg>
+    <p:spTree>
+      <p:nvGrpSpPr>
+        <p:cNvPr id="1" name=""/>
+        <p:cNvGrpSpPr/>
+        <p:nvPr/>
+      </p:nvGrpSpPr>
+      <p:grpSpPr>
+        <a:xfrm>
+          <a:off x="0" y="0"/>
+          <a:ext cx="0" cy="0"/>
+          <a:chOff x="0" y="0"/>
+          <a:chExt cx="0" cy="0"/>
+        </a:xfrm>
+      </p:grpSpPr>
+      <p:sp>
+        <p:nvSpPr>
+          <p:cNvPr id="2" name="Header Placeholder 1"/>
+          <p:cNvSpPr>
+            <a:spLocks noGrp="1"/>
+          </p:cNvSpPr>
+          <p:nvPr>
+            <p:ph type="hdr" sz="quarter"/>
+          </p:nvPr>
+        </p:nvSpPr>
+        <p:spPr>
+          <a:xfrm>
+            <a:off x="0" y="0"/>
+            <a:ext cx="2971800" cy="457200"/>
+          </a:xfrm>
+          <a:prstGeom prst="rect">
+            <a:avLst/>
+          </a:prstGeom>
+        </p:spPr>
+        <p:txBody>
+          <a:bodyPr vert="horz" lIns="91440" tIns="45720" rIns="91440" bIns="45720" rtlCol="0"/>
+          <a:lstStyle>
+            <a:lvl1pPr algn="l">
+              <a:defRPr sz="1200"/>
+            </a:lvl1pPr>
+          </a:lstStyle>
+          <a:p>
+            <a:endParaRPr lang="en-US"/>
+          </a:p>
+        </p:txBody>
+      </p:sp>
+      <p:sp>
+        <p:nvSpPr>
+          <p:cNvPr id="3" name="Date Placeholder 2"/>
+          <p:cNvSpPr>
+            <a:spLocks noGrp="1"/>
+          </p:cNvSpPr>
+          <p:nvPr>
+            <p:ph type="dt" idx="1"/>
+          </p:nvPr>
+        </p:nvSpPr>
+        <p:spPr>
+          <a:xfrm>
+            <a:off x="3884613" y="0"/>
+            <a:ext cx="2971800" cy="457200"/>
+          </a:xfrm>
+          <a:prstGeom prst="rect">
+            <a:avLst/>
+          </a:prstGeom>
+        </p:spPr>
+        <p:txBody>
+          <a:bodyPr vert="horz" lIns="91440" tIns="45720" rIns="91440" bIns="45720" rtlCol="0"/>
+          <a:lstStyle>
+            <a:lvl1pPr algn="r">
+              <a:defRPr sz="1200"/>
+            </a:lvl1pPr>
+          </a:lstStyle>
+          <a:p>
+            <a:fld id="{0F89C1C7-3DCD-1040-A9CF-14679D8B5DDD}" type="datetimeFigureOut">
+              <a:rPr lang="en-US" smtClean="0"/>
+              <a:t>10/17/16</a:t>
+            </a:fld>
+            <a:endParaRPr lang="en-US"/>
+          </a:p>
+        </p:txBody>
+      </p:sp>
+      <p:sp>
+        <p:nvSpPr>
+          <p:cNvPr id="4" name="Slide Image Placeholder 3"/>
+          <p:cNvSpPr>
+            <a:spLocks noGrp="1" noRot="1" noChangeAspect="1"/>
+          </p:cNvSpPr>
+          <p:nvPr>
+            <p:ph type="sldImg" idx="2"/>
+          </p:nvPr>
+        </p:nvSpPr>
+        <p:spPr>
+          <a:xfrm>
+            <a:off x="1143000" y="685800"/>
+            <a:ext cx="4572000" cy="3429000"/>
+          </a:xfrm>
+          <a:prstGeom prst="rect">
+            <a:avLst/>
+          </a:prstGeom>
+          <a:noFill/>
+          <a:ln w="12700">
+            <a:solidFill>
+              <a:prstClr val="black"/>
+            </a:solidFill>
+          </a:ln>
+        </p:spPr>
+        <p:txBody>
+          <a:bodyPr vert="horz" lIns="91440" tIns="45720" rIns="91440" bIns="45720" rtlCol="0" anchor="ctr"/>
+          <a:lstStyle/>
+          <a:p>
+            <a:endParaRPr lang="en-US"/>
+          </a:p>
+        </p:txBody>
+      </p:sp>
+      <p:sp>
+        <p:nvSpPr>
+          <p:cNvPr id="5" name="Notes Placeholder 4"/>
+          <p:cNvSpPr>
+            <a:spLocks noGrp="1"/>
+          </p:cNvSpPr>
+          <p:nvPr>
+            <p:ph type="body" sz="quarter" idx="3"/>
+          </p:nvPr>
+        </p:nvSpPr>
+        <p:spPr>
+          <a:xfrm>
+            <a:off x="685800" y="4343400"/>
+            <a:ext cx="5486400" cy="4114800"/>
+          </a:xfrm>
+          <a:prstGeom prst="rect">
+            <a:avLst/>
+          </a:prstGeom>
+        </p:spPr>
+        <p:txBody>
+          <a:bodyPr vert="horz" lIns="91440" tIns="45720" rIns="91440" bIns="45720" rtlCol="0"/>
+          <a:lstStyle/>
+          <a:p>
+            <a:pPr lvl="0"/>
+            <a:r>
+              <a:rPr lang="en-US" smtClean="0"/>
+              <a:t>Click to edit Master text styles</a:t>
+            </a:r>
+          </a:p>
+          <a:p>
+            <a:pPr lvl="1"/>
+            <a:r>
+              <a:rPr lang="en-US" smtClean="0"/>
+              <a:t>Second level</a:t>
+            </a:r>
+          </a:p>
+          <a:p>
+            <a:pPr lvl="2"/>
+            <a:r>
+              <a:rPr lang="en-US" smtClean="0"/>
+              <a:t>Third level</a:t>
+            </a:r>
+          </a:p>
+          <a:p>
+            <a:pPr lvl="3"/>
+            <a:r>
+              <a:rPr lang="en-US" smtClean="0"/>
+              <a:t>Fourth level</a:t>
+            </a:r>
+          </a:p>
+          <a:p>
+            <a:pPr lvl="4"/>
+            <a:r>
+              <a:rPr lang="en-US" smtClean="0"/>
+              <a:t>Fifth level</a:t>
+            </a:r>
+            <a:endParaRPr lang="en-US"/>
+          </a:p>
+        </p:txBody>
+      </p:sp>
+      <p:sp>
+        <p:nvSpPr>
+          <p:cNvPr id="6" name="Footer Placeholder 5"/>
+          <p:cNvSpPr>
+            <a:spLocks noGrp="1"/>
+          </p:cNvSpPr>
+          <p:nvPr>
+            <p:ph type="ftr" sz="quarter" idx="4"/>
+          </p:nvPr>
+        </p:nvSpPr>
+        <p:spPr>
+          <a:xfrm>
+            <a:off x="0" y="8685213"/>
+            <a:ext cx="2971800" cy="457200"/>
+          </a:xfrm>
+          <a:prstGeom prst="rect">
+            <a:avLst/>
+          </a:prstGeom>
+        </p:spPr>
+        <p:txBody>
+          <a:bodyPr vert="horz" lIns="91440" tIns="45720" rIns="91440" bIns="45720" rtlCol="0" anchor="b"/>
+          <a:lstStyle>
+            <a:lvl1pPr algn="l">
+              <a:defRPr sz="1200"/>
+            </a:lvl1pPr>
+          </a:lstStyle>
+          <a:p>
+            <a:endParaRPr lang="en-US"/>
+          </a:p>
+        </p:txBody>
+      </p:sp>
+      <p:sp>
+        <p:nvSpPr>
+          <p:cNvPr id="7" name="Slide Number Placeholder 6"/>
+          <p:cNvSpPr>
+            <a:spLocks noGrp="1"/>
+          </p:cNvSpPr>
+          <p:nvPr>
+            <p:ph type="sldNum" sz="quarter" idx="5"/>
+          </p:nvPr>
+        </p:nvSpPr>
+        <p:spPr>
+          <a:xfrm>
+            <a:off x="3884613" y="8685213"/>
+            <a:ext cx="2971800" cy="457200"/>
+          </a:xfrm>
+          <a:prstGeom prst="rect">
+            <a:avLst/>
+          </a:prstGeom>
+        </p:spPr>
+        <p:txBody>
+          <a:bodyPr vert="horz" lIns="91440" tIns="45720" rIns="91440" bIns="45720" rtlCol="0" anchor="b"/>
+          <a:lstStyle>
+            <a:lvl1pPr algn="r">
+              <a:defRPr sz="1200"/>
+            </a:lvl1pPr>
+          </a:lstStyle>
+          <a:p>
+            <a:fld id="{BB5E49A5-4136-284D-997B-48E1D791AD67}" type="slidenum">
+              <a:rPr lang="en-US" smtClean="0"/>
+              <a:t>‹#›</a:t>
+            </a:fld>
+            <a:endParaRPr lang="en-US"/>
+          </a:p>
+        </p:txBody>
+      </p:sp>
+    </p:spTree>
+    <p:extLst>
+      <p:ext uri="{BB962C8B-B14F-4D97-AF65-F5344CB8AC3E}">
+        <p14:creationId xmlns:p14="http://schemas.microsoft.com/office/powerpoint/2010/main" val="2623252185"/>
+      </p:ext>
+    </p:extLst>
+  </p:cSld>
+  <p:clrMap bg1="lt1" tx1="dk1" bg2="lt2" tx2="dk2" accent1="accent1" accent2="accent2" accent3="accent3" accent4="accent4" accent5="accent5" accent6="accent6" hlink="hlink" folHlink="folHlink"/>
+  <p:notesStyle>
+    <a:lvl1pPr marL="0" algn="l" defTabSz="457200" rtl="0" eaLnBrk="1" latinLnBrk="0" hangingPunct="1">
+      <a:defRPr sz="1200" kern="1200">
+        <a:solidFill>
+          <a:schemeClr val="tx1"/>
+        </a:solidFill>
+        <a:latin typeface="+mn-lt"/>
+        <a:ea typeface="+mn-ea"/>
+        <a:cs typeface="+mn-cs"/>
+      </a:defRPr>
+    </a:lvl1pPr>
+    <a:lvl2pPr marL="457200" algn="l" defTabSz="457200" rtl="0" eaLnBrk="1" latinLnBrk="0" hangingPunct="1">
+      <a:defRPr sz="1200" kern="1200">
+        <a:solidFill>
+          <a:schemeClr val="tx1"/>
+        </a:solidFill>
+        <a:latin typeface="+mn-lt"/>
+        <a:ea typeface="+mn-ea"/>
+        <a:cs typeface="+mn-cs"/>
+      </a:defRPr>
+    </a:lvl2pPr>
+    <a:lvl3pPr marL="914400" algn="l" defTabSz="457200" rtl="0" eaLnBrk="1" latinLnBrk="0" hangingPunct="1">
+      <a:defRPr sz="1200" kern="1200">
+        <a:solidFill>
+          <a:schemeClr val="tx1"/>
+        </a:solidFill>
+        <a:latin typeface="+mn-lt"/>
+        <a:ea typeface="+mn-ea"/>
+        <a:cs typeface="+mn-cs"/>
+      </a:defRPr>
+    </a:lvl3pPr>
+    <a:lvl4pPr marL="1371600" algn="l" defTabSz="457200" rtl="0" eaLnBrk="1" latinLnBrk="0" hangingPunct="1">
+      <a:defRPr sz="1200" kern="1200">
+        <a:solidFill>
+          <a:schemeClr val="tx1"/>
+        </a:solidFill>
+        <a:latin typeface="+mn-lt"/>
+        <a:ea typeface="+mn-ea"/>
+        <a:cs typeface="+mn-cs"/>
+      </a:defRPr>
+    </a:lvl4pPr>
+    <a:lvl5pPr marL="1828800" algn="l" defTabSz="457200" rtl="0" eaLnBrk="1" latinLnBrk="0" hangingPunct="1">
+      <a:defRPr sz="1200" kern="1200">
+        <a:solidFill>
+          <a:schemeClr val="tx1"/>
+        </a:solidFill>
+        <a:latin typeface="+mn-lt"/>
+        <a:ea typeface="+mn-ea"/>
+        <a:cs typeface="+mn-cs"/>
+      </a:defRPr>
+    </a:lvl5pPr>
+    <a:lvl6pPr marL="2286000" algn="l" defTabSz="457200" rtl="0" eaLnBrk="1" latinLnBrk="0" hangingPunct="1">
+      <a:defRPr sz="1200" kern="1200">
+        <a:solidFill>
+          <a:schemeClr val="tx1"/>
+        </a:solidFill>
+        <a:latin typeface="+mn-lt"/>
+        <a:ea typeface="+mn-ea"/>
+        <a:cs typeface="+mn-cs"/>
+      </a:defRPr>
+    </a:lvl6pPr>
+    <a:lvl7pPr marL="2743200" algn="l" defTabSz="457200" rtl="0" eaLnBrk="1" latinLnBrk="0" hangingPunct="1">
+      <a:defRPr sz="1200" kern="1200">
+        <a:solidFill>
+          <a:schemeClr val="tx1"/>
+        </a:solidFill>
+        <a:latin typeface="+mn-lt"/>
+        <a:ea typeface="+mn-ea"/>
+        <a:cs typeface="+mn-cs"/>
+      </a:defRPr>
+    </a:lvl7pPr>
+    <a:lvl8pPr marL="3200400" algn="l" defTabSz="457200" rtl="0" eaLnBrk="1" latinLnBrk="0" hangingPunct="1">
+      <a:defRPr sz="1200" kern="1200">
+        <a:solidFill>
+          <a:schemeClr val="tx1"/>
+        </a:solidFill>
+        <a:latin typeface="+mn-lt"/>
+        <a:ea typeface="+mn-ea"/>
+        <a:cs typeface="+mn-cs"/>
+      </a:defRPr>
+    </a:lvl8pPr>
+    <a:lvl9pPr marL="3657600" algn="l" defTabSz="457200" rtl="0" eaLnBrk="1" latinLnBrk="0" hangingPunct="1">
+      <a:defRPr sz="1200" kern="1200">
+        <a:solidFill>
+          <a:schemeClr val="tx1"/>
+        </a:solidFill>
+        <a:latin typeface="+mn-lt"/>
+        <a:ea typeface="+mn-ea"/>
+        <a:cs typeface="+mn-cs"/>
+      </a:defRPr>
+    </a:lvl9pPr>
+  </p:notesStyle>
+</p:notesMaster>
+</file>
+
+<file path=ppt/notesSlides/notesSlide1.xml><?xml version="1.0" encoding="utf-8"?>
+<p:notes xmlns:a="http://schemas.openxmlformats.org/drawingml/2006/main" xmlns:p="http://schemas.openxmlformats.org/presentationml/2006/main" xmlns:r="http://schemas.openxmlformats.org/officeDocument/2006/relationships">
+  <p:cSld>
+    <p:spTree>
+      <p:nvGrpSpPr>
+        <p:cNvPr id="1" name=""/>
+        <p:cNvGrpSpPr/>
+        <p:nvPr/>
+      </p:nvGrpSpPr>
+      <p:grpSpPr>
+        <a:xfrm>
+          <a:off x="0" y="0"/>
+          <a:ext cx="0" cy="0"/>
+          <a:chOff x="0" y="0"/>
+          <a:chExt cx="0" cy="0"/>
+        </a:xfrm>
+      </p:grpSpPr>
+      <p:sp>
+        <p:nvSpPr>
+          <p:cNvPr id="2" name="Slide Image Placeholder 1"/>
+          <p:cNvSpPr>
+            <a:spLocks noGrp="1"/>
+          </p:cNvSpPr>
+          <p:nvPr>
+            <p:ph type="sldImg" idx="2"/>
+          </p:nvPr>
+        </p:nvSpPr>
+        <p:spPr/>
+      </p:sp>
+      <p:sp>
+        <p:nvSpPr>
+          <p:cNvPr id="3" name="Notes Placeholder 2"/>
+          <p:cNvSpPr>
+            <a:spLocks noGrp="1"/>
+          </p:cNvSpPr>
+          <p:nvPr>
+            <p:ph type="body" idx="3" sz="quarter"/>
+          </p:nvPr>
+        </p:nvSpPr>
+        <p:spPr/>
+        <p:txBody>
+          <a:bodyPr/>
+          <a:lstStyle/>
+          <a:p>
+            <a:r>
+              <a:t>Image should not break text extraction.</a:t>
+            </a:r>
+          </a:p>
+        </p:txBody>
+      </p:sp>
+      <p:sp>
+        <p:nvSpPr>
+          <p:cNvPr id="4" name="Slide Number Placeholder 3"/>
+          <p:cNvSpPr>
+            <a:spLocks noGrp="1"/>
+          </p:cNvSpPr>
+          <p:nvPr>
+            <p:ph type="sldNum" idx="5" sz="quarter"/>
+          </p:nvPr>
+        </p:nvSpPr>
+        <p:spPr/>
+      </p:sp>
+    </p:spTree>
+  </p:cSld>
+  <p:clrMapOvr>
+    <a:masterClrMapping/>
+  </p:clrMapOvr>
+</p:notes>
 </file>
 
 <file path=ppt/slideLayouts/slideLayout1.xml><?xml version="1.0" encoding="utf-8"?>
@@ -131,13 +546,7 @@
       </p:grpSpPr>
       <p:sp>
         <p:nvSpPr>
-          <p:cNvPr id="2" name="Title 1">
-            <a:extLst>
-              <a:ext uri="{FF2B5EF4-FFF2-40B4-BE49-F238E27FC236}">
-                <a16:creationId xmlns:a16="http://schemas.microsoft.com/office/drawing/2014/main" id="{41AC1114-1653-AF05-9598-4D3A5B0F3884}"/>
-              </a:ext>
-            </a:extLst>
-          </p:cNvPr>
+          <p:cNvPr id="2" name="Title 1"/>
           <p:cNvSpPr>
             <a:spLocks noGrp="1"/>
           </p:cNvSpPr>
@@ -147,34 +556,25 @@
         </p:nvSpPr>
         <p:spPr>
           <a:xfrm>
-            <a:off x="1524000" y="1122363"/>
-            <a:ext cx="9144000" cy="2387600"/>
+            <a:off x="685800" y="2130425"/>
+            <a:ext cx="7772400" cy="1470025"/>
           </a:xfrm>
         </p:spPr>
         <p:txBody>
-          <a:bodyPr anchor="b"/>
-          <a:lstStyle>
-            <a:lvl1pPr algn="ctr">
-              <a:defRPr sz="6000"/>
-            </a:lvl1pPr>
-          </a:lstStyle>
-          <a:p>
-            <a:r>
-              <a:rPr lang="en-US"/>
+          <a:bodyPr/>
+          <a:lstStyle/>
+          <a:p>
+            <a:r>
+              <a:rPr lang="en-US" smtClean="0"/>
               <a:t>Click to edit Master title style</a:t>
             </a:r>
-          </a:p>
-        </p:txBody>
-      </p:sp>
-      <p:sp>
-        <p:nvSpPr>
-          <p:cNvPr id="3" name="Subtitle 2">
-            <a:extLst>
-              <a:ext uri="{FF2B5EF4-FFF2-40B4-BE49-F238E27FC236}">
-                <a16:creationId xmlns:a16="http://schemas.microsoft.com/office/drawing/2014/main" id="{88FBEF53-CF09-779D-0491-3C2D62ADE9CC}"/>
-              </a:ext>
-            </a:extLst>
-          </p:cNvPr>
+            <a:endParaRPr lang="en-US"/>
+          </a:p>
+        </p:txBody>
+      </p:sp>
+      <p:sp>
+        <p:nvSpPr>
+          <p:cNvPr id="3" name="Subtitle 2"/>
           <p:cNvSpPr>
             <a:spLocks noGrp="1"/>
           </p:cNvSpPr>
@@ -184,8 +584,8 @@
         </p:nvSpPr>
         <p:spPr>
           <a:xfrm>
-            <a:off x="1524000" y="3602038"/>
-            <a:ext cx="9144000" cy="1655762"/>
+            <a:off x="1371600" y="3886200"/>
+            <a:ext cx="6400800" cy="1752600"/>
           </a:xfrm>
         </p:spPr>
         <p:txBody>
@@ -193,58 +593,107 @@
           <a:lstStyle>
             <a:lvl1pPr marL="0" indent="0" algn="ctr">
               <a:buNone/>
-              <a:defRPr sz="2400"/>
+              <a:defRPr>
+                <a:solidFill>
+                  <a:schemeClr val="tx1">
+                    <a:tint val="75000"/>
+                  </a:schemeClr>
+                </a:solidFill>
+              </a:defRPr>
             </a:lvl1pPr>
             <a:lvl2pPr marL="457200" indent="0" algn="ctr">
               <a:buNone/>
-              <a:defRPr sz="2000"/>
+              <a:defRPr>
+                <a:solidFill>
+                  <a:schemeClr val="tx1">
+                    <a:tint val="75000"/>
+                  </a:schemeClr>
+                </a:solidFill>
+              </a:defRPr>
             </a:lvl2pPr>
             <a:lvl3pPr marL="914400" indent="0" algn="ctr">
               <a:buNone/>
-              <a:defRPr sz="1800"/>
+              <a:defRPr>
+                <a:solidFill>
+                  <a:schemeClr val="tx1">
+                    <a:tint val="75000"/>
+                  </a:schemeClr>
+                </a:solidFill>
+              </a:defRPr>
             </a:lvl3pPr>
             <a:lvl4pPr marL="1371600" indent="0" algn="ctr">
               <a:buNone/>
-              <a:defRPr sz="1600"/>
+              <a:defRPr>
+                <a:solidFill>
+                  <a:schemeClr val="tx1">
+                    <a:tint val="75000"/>
+                  </a:schemeClr>
+                </a:solidFill>
+              </a:defRPr>
             </a:lvl4pPr>
             <a:lvl5pPr marL="1828800" indent="0" algn="ctr">
               <a:buNone/>
-              <a:defRPr sz="1600"/>
+              <a:defRPr>
+                <a:solidFill>
+                  <a:schemeClr val="tx1">
+                    <a:tint val="75000"/>
+                  </a:schemeClr>
+                </a:solidFill>
+              </a:defRPr>
             </a:lvl5pPr>
             <a:lvl6pPr marL="2286000" indent="0" algn="ctr">
               <a:buNone/>
-              <a:defRPr sz="1600"/>
+              <a:defRPr>
+                <a:solidFill>
+                  <a:schemeClr val="tx1">
+                    <a:tint val="75000"/>
+                  </a:schemeClr>
+                </a:solidFill>
+              </a:defRPr>
             </a:lvl6pPr>
             <a:lvl7pPr marL="2743200" indent="0" algn="ctr">
               <a:buNone/>
-              <a:defRPr sz="1600"/>
+              <a:defRPr>
+                <a:solidFill>
+                  <a:schemeClr val="tx1">
+                    <a:tint val="75000"/>
+                  </a:schemeClr>
+                </a:solidFill>
+              </a:defRPr>
             </a:lvl7pPr>
             <a:lvl8pPr marL="3200400" indent="0" algn="ctr">
               <a:buNone/>
-              <a:defRPr sz="1600"/>
+              <a:defRPr>
+                <a:solidFill>
+                  <a:schemeClr val="tx1">
+                    <a:tint val="75000"/>
+                  </a:schemeClr>
+                </a:solidFill>
+              </a:defRPr>
             </a:lvl8pPr>
             <a:lvl9pPr marL="3657600" indent="0" algn="ctr">
               <a:buNone/>
-              <a:defRPr sz="1600"/>
+              <a:defRPr>
+                <a:solidFill>
+                  <a:schemeClr val="tx1">
+                    <a:tint val="75000"/>
+                  </a:schemeClr>
+                </a:solidFill>
+              </a:defRPr>
             </a:lvl9pPr>
           </a:lstStyle>
           <a:p>
             <a:r>
-              <a:rPr lang="en-US"/>
+              <a:rPr lang="en-US" smtClean="0"/>
               <a:t>Click to edit Master subtitle style</a:t>
             </a:r>
-          </a:p>
-        </p:txBody>
-      </p:sp>
-      <p:sp>
-        <p:nvSpPr>
-          <p:cNvPr id="4" name="Date Placeholder 3">
-            <a:extLst>
-              <a:ext uri="{FF2B5EF4-FFF2-40B4-BE49-F238E27FC236}">
-                <a16:creationId xmlns:a16="http://schemas.microsoft.com/office/drawing/2014/main" id="{EBAF7C0D-AE69-1A87-7043-E4E949E4DABD}"/>
-              </a:ext>
-            </a:extLst>
-          </p:cNvPr>
+            <a:endParaRPr lang="en-US"/>
+          </a:p>
+        </p:txBody>
+      </p:sp>
+      <p:sp>
+        <p:nvSpPr>
+          <p:cNvPr id="4" name="Date Placeholder 3"/>
           <p:cNvSpPr>
             <a:spLocks noGrp="1"/>
           </p:cNvSpPr>
@@ -257,9 +706,9 @@
           <a:bodyPr/>
           <a:lstStyle/>
           <a:p>
-            <a:fld id="{22C88FD7-B5A4-B541-9894-CD062EA3E37C}" type="datetimeFigureOut">
-              <a:rPr lang="en-US" smtClean="0"/>
-              <a:t>1/30/26</a:t>
+            <a:fld id="{5BCAD085-E8A6-8845-BD4E-CB4CCA059FC4}" type="datetimeFigureOut">
+              <a:rPr lang="en-US" smtClean="0"/>
+              <a:t>1/27/13</a:t>
             </a:fld>
             <a:endParaRPr lang="en-US"/>
           </a:p>
@@ -267,13 +716,7 @@
       </p:sp>
       <p:sp>
         <p:nvSpPr>
-          <p:cNvPr id="5" name="Footer Placeholder 4">
-            <a:extLst>
-              <a:ext uri="{FF2B5EF4-FFF2-40B4-BE49-F238E27FC236}">
-                <a16:creationId xmlns:a16="http://schemas.microsoft.com/office/drawing/2014/main" id="{9DA94443-54D3-2C10-7D3D-2C9C14B58E7E}"/>
-              </a:ext>
-            </a:extLst>
-          </p:cNvPr>
+          <p:cNvPr id="5" name="Footer Placeholder 4"/>
           <p:cNvSpPr>
             <a:spLocks noGrp="1"/>
           </p:cNvSpPr>
@@ -292,13 +735,7 @@
       </p:sp>
       <p:sp>
         <p:nvSpPr>
-          <p:cNvPr id="6" name="Slide Number Placeholder 5">
-            <a:extLst>
-              <a:ext uri="{FF2B5EF4-FFF2-40B4-BE49-F238E27FC236}">
-                <a16:creationId xmlns:a16="http://schemas.microsoft.com/office/drawing/2014/main" id="{651543C9-CA57-4173-374A-052EA6DBDD4F}"/>
-              </a:ext>
-            </a:extLst>
-          </p:cNvPr>
+          <p:cNvPr id="6" name="Slide Number Placeholder 5"/>
           <p:cNvSpPr>
             <a:spLocks noGrp="1"/>
           </p:cNvSpPr>
@@ -311,7 +748,7 @@
           <a:bodyPr/>
           <a:lstStyle/>
           <a:p>
-            <a:fld id="{F32E41F8-49F7-CD4A-BC3D-8F020394F209}" type="slidenum">
+            <a:fld id="{C1FF6DA9-008F-8B48-92A6-B652298478BF}" type="slidenum">
               <a:rPr lang="en-US" smtClean="0"/>
               <a:t>‹#›</a:t>
             </a:fld>
@@ -322,7 +759,7 @@
     </p:spTree>
     <p:extLst>
       <p:ext uri="{BB962C8B-B14F-4D97-AF65-F5344CB8AC3E}">
-        <p14:creationId xmlns:p14="http://schemas.microsoft.com/office/powerpoint/2010/main" val="4270559844"/>
+        <p14:creationId xmlns:p14="http://schemas.microsoft.com/office/powerpoint/2010/main" val="3168075583"/>
       </p:ext>
     </p:extLst>
   </p:cSld>
@@ -351,13 +788,7 @@
       </p:grpSpPr>
       <p:sp>
         <p:nvSpPr>
-          <p:cNvPr id="2" name="Title 1">
-            <a:extLst>
-              <a:ext uri="{FF2B5EF4-FFF2-40B4-BE49-F238E27FC236}">
-                <a16:creationId xmlns:a16="http://schemas.microsoft.com/office/drawing/2014/main" id="{03E1519F-FC02-1A38-7A6D-C94E515D420A}"/>
-              </a:ext>
-            </a:extLst>
-          </p:cNvPr>
+          <p:cNvPr id="2" name="Title 1"/>
           <p:cNvSpPr>
             <a:spLocks noGrp="1"/>
           </p:cNvSpPr>
@@ -371,21 +802,16 @@
           <a:lstStyle/>
           <a:p>
             <a:r>
-              <a:rPr lang="en-US"/>
+              <a:rPr lang="en-US" smtClean="0"/>
               <a:t>Click to edit Master title style</a:t>
             </a:r>
-          </a:p>
-        </p:txBody>
-      </p:sp>
-      <p:sp>
-        <p:nvSpPr>
-          <p:cNvPr id="3" name="Vertical Text Placeholder 2">
-            <a:extLst>
-              <a:ext uri="{FF2B5EF4-FFF2-40B4-BE49-F238E27FC236}">
-                <a16:creationId xmlns:a16="http://schemas.microsoft.com/office/drawing/2014/main" id="{13941493-6790-8142-00E6-2C12A2ED5FE6}"/>
-              </a:ext>
-            </a:extLst>
-          </p:cNvPr>
+            <a:endParaRPr lang="en-US"/>
+          </a:p>
+        </p:txBody>
+      </p:sp>
+      <p:sp>
+        <p:nvSpPr>
+          <p:cNvPr id="3" name="Vertical Text Placeholder 2"/>
           <p:cNvSpPr>
             <a:spLocks noGrp="1"/>
           </p:cNvSpPr>
@@ -400,49 +826,44 @@
           <a:p>
             <a:pPr lvl="0"/>
             <a:r>
-              <a:rPr lang="en-US"/>
+              <a:rPr lang="en-US" smtClean="0"/>
               <a:t>Click to edit Master text styles</a:t>
             </a:r>
           </a:p>
           <a:p>
             <a:pPr lvl="1"/>
             <a:r>
-              <a:rPr lang="en-US"/>
+              <a:rPr lang="en-US" smtClean="0"/>
               <a:t>Second level</a:t>
             </a:r>
           </a:p>
           <a:p>
             <a:pPr lvl="2"/>
             <a:r>
-              <a:rPr lang="en-US"/>
+              <a:rPr lang="en-US" smtClean="0"/>
               <a:t>Third level</a:t>
             </a:r>
           </a:p>
           <a:p>
             <a:pPr lvl="3"/>
             <a:r>
-              <a:rPr lang="en-US"/>
+              <a:rPr lang="en-US" smtClean="0"/>
               <a:t>Fourth level</a:t>
             </a:r>
           </a:p>
           <a:p>
             <a:pPr lvl="4"/>
             <a:r>
-              <a:rPr lang="en-US"/>
+              <a:rPr lang="en-US" smtClean="0"/>
               <a:t>Fifth level</a:t>
             </a:r>
-          </a:p>
-        </p:txBody>
-      </p:sp>
-      <p:sp>
-        <p:nvSpPr>
-          <p:cNvPr id="4" name="Date Placeholder 3">
-            <a:extLst>
-              <a:ext uri="{FF2B5EF4-FFF2-40B4-BE49-F238E27FC236}">
-                <a16:creationId xmlns:a16="http://schemas.microsoft.com/office/drawing/2014/main" id="{861EBCA9-DA92-1EF7-9880-0433CFD12690}"/>
-              </a:ext>
-            </a:extLst>
-          </p:cNvPr>
+            <a:endParaRPr lang="en-US"/>
+          </a:p>
+        </p:txBody>
+      </p:sp>
+      <p:sp>
+        <p:nvSpPr>
+          <p:cNvPr id="4" name="Date Placeholder 3"/>
           <p:cNvSpPr>
             <a:spLocks noGrp="1"/>
           </p:cNvSpPr>
@@ -455,9 +876,9 @@
           <a:bodyPr/>
           <a:lstStyle/>
           <a:p>
-            <a:fld id="{22C88FD7-B5A4-B541-9894-CD062EA3E37C}" type="datetimeFigureOut">
-              <a:rPr lang="en-US" smtClean="0"/>
-              <a:t>1/30/26</a:t>
+            <a:fld id="{5BCAD085-E8A6-8845-BD4E-CB4CCA059FC4}" type="datetimeFigureOut">
+              <a:rPr lang="en-US" smtClean="0"/>
+              <a:t>1/27/13</a:t>
             </a:fld>
             <a:endParaRPr lang="en-US"/>
           </a:p>
@@ -465,13 +886,7 @@
       </p:sp>
       <p:sp>
         <p:nvSpPr>
-          <p:cNvPr id="5" name="Footer Placeholder 4">
-            <a:extLst>
-              <a:ext uri="{FF2B5EF4-FFF2-40B4-BE49-F238E27FC236}">
-                <a16:creationId xmlns:a16="http://schemas.microsoft.com/office/drawing/2014/main" id="{21EC0930-29D0-C3C0-5183-37D554763D6C}"/>
-              </a:ext>
-            </a:extLst>
-          </p:cNvPr>
+          <p:cNvPr id="5" name="Footer Placeholder 4"/>
           <p:cNvSpPr>
             <a:spLocks noGrp="1"/>
           </p:cNvSpPr>
@@ -490,13 +905,7 @@
       </p:sp>
       <p:sp>
         <p:nvSpPr>
-          <p:cNvPr id="6" name="Slide Number Placeholder 5">
-            <a:extLst>
-              <a:ext uri="{FF2B5EF4-FFF2-40B4-BE49-F238E27FC236}">
-                <a16:creationId xmlns:a16="http://schemas.microsoft.com/office/drawing/2014/main" id="{C481FA23-2836-B9E4-ED54-41874E7B46A0}"/>
-              </a:ext>
-            </a:extLst>
-          </p:cNvPr>
+          <p:cNvPr id="6" name="Slide Number Placeholder 5"/>
           <p:cNvSpPr>
             <a:spLocks noGrp="1"/>
           </p:cNvSpPr>
@@ -509,7 +918,7 @@
           <a:bodyPr/>
           <a:lstStyle/>
           <a:p>
-            <a:fld id="{F32E41F8-49F7-CD4A-BC3D-8F020394F209}" type="slidenum">
+            <a:fld id="{C1FF6DA9-008F-8B48-92A6-B652298478BF}" type="slidenum">
               <a:rPr lang="en-US" smtClean="0"/>
               <a:t>‹#›</a:t>
             </a:fld>
@@ -520,7 +929,7 @@
     </p:spTree>
     <p:extLst>
       <p:ext uri="{BB962C8B-B14F-4D97-AF65-F5344CB8AC3E}">
-        <p14:creationId xmlns:p14="http://schemas.microsoft.com/office/powerpoint/2010/main" val="788998262"/>
+        <p14:creationId xmlns:p14="http://schemas.microsoft.com/office/powerpoint/2010/main" val="2910927964"/>
       </p:ext>
     </p:extLst>
   </p:cSld>
@@ -549,13 +958,7 @@
       </p:grpSpPr>
       <p:sp>
         <p:nvSpPr>
-          <p:cNvPr id="2" name="Vertical Title 1">
-            <a:extLst>
-              <a:ext uri="{FF2B5EF4-FFF2-40B4-BE49-F238E27FC236}">
-                <a16:creationId xmlns:a16="http://schemas.microsoft.com/office/drawing/2014/main" id="{0AE63B05-7084-3091-1DEC-8BD424968AD1}"/>
-              </a:ext>
-            </a:extLst>
-          </p:cNvPr>
+          <p:cNvPr id="2" name="Vertical Title 1"/>
           <p:cNvSpPr>
             <a:spLocks noGrp="1"/>
           </p:cNvSpPr>
@@ -565,8 +968,8 @@
         </p:nvSpPr>
         <p:spPr>
           <a:xfrm>
-            <a:off x="8724900" y="365125"/>
-            <a:ext cx="2628900" cy="5811838"/>
+            <a:off x="6629400" y="274638"/>
+            <a:ext cx="2057400" cy="5851525"/>
           </a:xfrm>
         </p:spPr>
         <p:txBody>
@@ -574,21 +977,16 @@
           <a:lstStyle/>
           <a:p>
             <a:r>
-              <a:rPr lang="en-US"/>
+              <a:rPr lang="en-US" smtClean="0"/>
               <a:t>Click to edit Master title style</a:t>
             </a:r>
-          </a:p>
-        </p:txBody>
-      </p:sp>
-      <p:sp>
-        <p:nvSpPr>
-          <p:cNvPr id="3" name="Vertical Text Placeholder 2">
-            <a:extLst>
-              <a:ext uri="{FF2B5EF4-FFF2-40B4-BE49-F238E27FC236}">
-                <a16:creationId xmlns:a16="http://schemas.microsoft.com/office/drawing/2014/main" id="{7804C4F4-BE9E-361D-FC01-8B5831096719}"/>
-              </a:ext>
-            </a:extLst>
-          </p:cNvPr>
+            <a:endParaRPr lang="en-US"/>
+          </a:p>
+        </p:txBody>
+      </p:sp>
+      <p:sp>
+        <p:nvSpPr>
+          <p:cNvPr id="3" name="Vertical Text Placeholder 2"/>
           <p:cNvSpPr>
             <a:spLocks noGrp="1"/>
           </p:cNvSpPr>
@@ -598,8 +996,8 @@
         </p:nvSpPr>
         <p:spPr>
           <a:xfrm>
-            <a:off x="838200" y="365125"/>
-            <a:ext cx="7734300" cy="5811838"/>
+            <a:off x="457200" y="274638"/>
+            <a:ext cx="6019800" cy="5851525"/>
           </a:xfrm>
         </p:spPr>
         <p:txBody>
@@ -608,49 +1006,44 @@
           <a:p>
             <a:pPr lvl="0"/>
             <a:r>
-              <a:rPr lang="en-US"/>
+              <a:rPr lang="en-US" smtClean="0"/>
               <a:t>Click to edit Master text styles</a:t>
             </a:r>
           </a:p>
           <a:p>
             <a:pPr lvl="1"/>
             <a:r>
-              <a:rPr lang="en-US"/>
+              <a:rPr lang="en-US" smtClean="0"/>
               <a:t>Second level</a:t>
             </a:r>
           </a:p>
           <a:p>
             <a:pPr lvl="2"/>
             <a:r>
-              <a:rPr lang="en-US"/>
+              <a:rPr lang="en-US" smtClean="0"/>
               <a:t>Third level</a:t>
             </a:r>
           </a:p>
           <a:p>
             <a:pPr lvl="3"/>
             <a:r>
-              <a:rPr lang="en-US"/>
+              <a:rPr lang="en-US" smtClean="0"/>
               <a:t>Fourth level</a:t>
             </a:r>
           </a:p>
           <a:p>
             <a:pPr lvl="4"/>
             <a:r>
-              <a:rPr lang="en-US"/>
+              <a:rPr lang="en-US" smtClean="0"/>
               <a:t>Fifth level</a:t>
             </a:r>
-          </a:p>
-        </p:txBody>
-      </p:sp>
-      <p:sp>
-        <p:nvSpPr>
-          <p:cNvPr id="4" name="Date Placeholder 3">
-            <a:extLst>
-              <a:ext uri="{FF2B5EF4-FFF2-40B4-BE49-F238E27FC236}">
-                <a16:creationId xmlns:a16="http://schemas.microsoft.com/office/drawing/2014/main" id="{E3317A4B-8991-91ED-F1F4-C81F6A73C4CC}"/>
-              </a:ext>
-            </a:extLst>
-          </p:cNvPr>
+            <a:endParaRPr lang="en-US"/>
+          </a:p>
+        </p:txBody>
+      </p:sp>
+      <p:sp>
+        <p:nvSpPr>
+          <p:cNvPr id="4" name="Date Placeholder 3"/>
           <p:cNvSpPr>
             <a:spLocks noGrp="1"/>
           </p:cNvSpPr>
@@ -663,9 +1056,9 @@
           <a:bodyPr/>
           <a:lstStyle/>
           <a:p>
-            <a:fld id="{22C88FD7-B5A4-B541-9894-CD062EA3E37C}" type="datetimeFigureOut">
-              <a:rPr lang="en-US" smtClean="0"/>
-              <a:t>1/30/26</a:t>
+            <a:fld id="{5BCAD085-E8A6-8845-BD4E-CB4CCA059FC4}" type="datetimeFigureOut">
+              <a:rPr lang="en-US" smtClean="0"/>
+              <a:t>1/27/13</a:t>
             </a:fld>
             <a:endParaRPr lang="en-US"/>
           </a:p>
@@ -673,13 +1066,7 @@
       </p:sp>
       <p:sp>
         <p:nvSpPr>
-          <p:cNvPr id="5" name="Footer Placeholder 4">
-            <a:extLst>
-              <a:ext uri="{FF2B5EF4-FFF2-40B4-BE49-F238E27FC236}">
-                <a16:creationId xmlns:a16="http://schemas.microsoft.com/office/drawing/2014/main" id="{4A913C4F-7175-90EE-C2DA-938A84216EB2}"/>
-              </a:ext>
-            </a:extLst>
-          </p:cNvPr>
+          <p:cNvPr id="5" name="Footer Placeholder 4"/>
           <p:cNvSpPr>
             <a:spLocks noGrp="1"/>
           </p:cNvSpPr>
@@ -698,13 +1085,7 @@
       </p:sp>
       <p:sp>
         <p:nvSpPr>
-          <p:cNvPr id="6" name="Slide Number Placeholder 5">
-            <a:extLst>
-              <a:ext uri="{FF2B5EF4-FFF2-40B4-BE49-F238E27FC236}">
-                <a16:creationId xmlns:a16="http://schemas.microsoft.com/office/drawing/2014/main" id="{09B7CC5D-1D14-5C5B-FE9C-D23F44735A6F}"/>
-              </a:ext>
-            </a:extLst>
-          </p:cNvPr>
+          <p:cNvPr id="6" name="Slide Number Placeholder 5"/>
           <p:cNvSpPr>
             <a:spLocks noGrp="1"/>
           </p:cNvSpPr>
@@ -717,7 +1098,7 @@
           <a:bodyPr/>
           <a:lstStyle/>
           <a:p>
-            <a:fld id="{F32E41F8-49F7-CD4A-BC3D-8F020394F209}" type="slidenum">
+            <a:fld id="{C1FF6DA9-008F-8B48-92A6-B652298478BF}" type="slidenum">
               <a:rPr lang="en-US" smtClean="0"/>
               <a:t>‹#›</a:t>
             </a:fld>
@@ -728,7 +1109,7 @@
     </p:spTree>
     <p:extLst>
       <p:ext uri="{BB962C8B-B14F-4D97-AF65-F5344CB8AC3E}">
-        <p14:creationId xmlns:p14="http://schemas.microsoft.com/office/powerpoint/2010/main" val="4199303654"/>
+        <p14:creationId xmlns:p14="http://schemas.microsoft.com/office/powerpoint/2010/main" val="3612223792"/>
       </p:ext>
     </p:extLst>
   </p:cSld>
@@ -757,13 +1138,7 @@
       </p:grpSpPr>
       <p:sp>
         <p:nvSpPr>
-          <p:cNvPr id="2" name="Title 1">
-            <a:extLst>
-              <a:ext uri="{FF2B5EF4-FFF2-40B4-BE49-F238E27FC236}">
-                <a16:creationId xmlns:a16="http://schemas.microsoft.com/office/drawing/2014/main" id="{19DD163F-4CC4-2D46-59E2-2F12B542B3A0}"/>
-              </a:ext>
-            </a:extLst>
-          </p:cNvPr>
+          <p:cNvPr id="2" name="Title 1"/>
           <p:cNvSpPr>
             <a:spLocks noGrp="1"/>
           </p:cNvSpPr>
@@ -777,21 +1152,16 @@
           <a:lstStyle/>
           <a:p>
             <a:r>
-              <a:rPr lang="en-US"/>
+              <a:rPr lang="en-US" smtClean="0"/>
               <a:t>Click to edit Master title style</a:t>
             </a:r>
-          </a:p>
-        </p:txBody>
-      </p:sp>
-      <p:sp>
-        <p:nvSpPr>
-          <p:cNvPr id="3" name="Content Placeholder 2">
-            <a:extLst>
-              <a:ext uri="{FF2B5EF4-FFF2-40B4-BE49-F238E27FC236}">
-                <a16:creationId xmlns:a16="http://schemas.microsoft.com/office/drawing/2014/main" id="{6CEB3982-F6BD-E8DA-7978-1B93DCB386A1}"/>
-              </a:ext>
-            </a:extLst>
-          </p:cNvPr>
+            <a:endParaRPr lang="en-US"/>
+          </a:p>
+        </p:txBody>
+      </p:sp>
+      <p:sp>
+        <p:nvSpPr>
+          <p:cNvPr id="3" name="Content Placeholder 2"/>
           <p:cNvSpPr>
             <a:spLocks noGrp="1"/>
           </p:cNvSpPr>
@@ -806,49 +1176,44 @@
           <a:p>
             <a:pPr lvl="0"/>
             <a:r>
-              <a:rPr lang="en-US"/>
+              <a:rPr lang="en-US" smtClean="0"/>
               <a:t>Click to edit Master text styles</a:t>
             </a:r>
           </a:p>
           <a:p>
             <a:pPr lvl="1"/>
             <a:r>
-              <a:rPr lang="en-US"/>
+              <a:rPr lang="en-US" smtClean="0"/>
               <a:t>Second level</a:t>
             </a:r>
           </a:p>
           <a:p>
             <a:pPr lvl="2"/>
             <a:r>
-              <a:rPr lang="en-US"/>
+              <a:rPr lang="en-US" smtClean="0"/>
               <a:t>Third level</a:t>
             </a:r>
           </a:p>
           <a:p>
             <a:pPr lvl="3"/>
             <a:r>
-              <a:rPr lang="en-US"/>
+              <a:rPr lang="en-US" smtClean="0"/>
               <a:t>Fourth level</a:t>
             </a:r>
           </a:p>
           <a:p>
             <a:pPr lvl="4"/>
             <a:r>
-              <a:rPr lang="en-US"/>
+              <a:rPr lang="en-US" smtClean="0"/>
               <a:t>Fifth level</a:t>
             </a:r>
-          </a:p>
-        </p:txBody>
-      </p:sp>
-      <p:sp>
-        <p:nvSpPr>
-          <p:cNvPr id="4" name="Date Placeholder 3">
-            <a:extLst>
-              <a:ext uri="{FF2B5EF4-FFF2-40B4-BE49-F238E27FC236}">
-                <a16:creationId xmlns:a16="http://schemas.microsoft.com/office/drawing/2014/main" id="{7E20A8DA-3504-AAE2-E76F-A49F889016F7}"/>
-              </a:ext>
-            </a:extLst>
-          </p:cNvPr>
+            <a:endParaRPr lang="en-US"/>
+          </a:p>
+        </p:txBody>
+      </p:sp>
+      <p:sp>
+        <p:nvSpPr>
+          <p:cNvPr id="4" name="Date Placeholder 3"/>
           <p:cNvSpPr>
             <a:spLocks noGrp="1"/>
           </p:cNvSpPr>
@@ -861,9 +1226,9 @@
           <a:bodyPr/>
           <a:lstStyle/>
           <a:p>
-            <a:fld id="{22C88FD7-B5A4-B541-9894-CD062EA3E37C}" type="datetimeFigureOut">
-              <a:rPr lang="en-US" smtClean="0"/>
-              <a:t>1/30/26</a:t>
+            <a:fld id="{5BCAD085-E8A6-8845-BD4E-CB4CCA059FC4}" type="datetimeFigureOut">
+              <a:rPr lang="en-US" smtClean="0"/>
+              <a:t>1/27/13</a:t>
             </a:fld>
             <a:endParaRPr lang="en-US"/>
           </a:p>
@@ -871,13 +1236,7 @@
       </p:sp>
       <p:sp>
         <p:nvSpPr>
-          <p:cNvPr id="5" name="Footer Placeholder 4">
-            <a:extLst>
-              <a:ext uri="{FF2B5EF4-FFF2-40B4-BE49-F238E27FC236}">
-                <a16:creationId xmlns:a16="http://schemas.microsoft.com/office/drawing/2014/main" id="{C29A043C-7E1C-960A-9CD9-C8BFB151BC0C}"/>
-              </a:ext>
-            </a:extLst>
-          </p:cNvPr>
+          <p:cNvPr id="5" name="Footer Placeholder 4"/>
           <p:cNvSpPr>
             <a:spLocks noGrp="1"/>
           </p:cNvSpPr>
@@ -896,13 +1255,7 @@
       </p:sp>
       <p:sp>
         <p:nvSpPr>
-          <p:cNvPr id="6" name="Slide Number Placeholder 5">
-            <a:extLst>
-              <a:ext uri="{FF2B5EF4-FFF2-40B4-BE49-F238E27FC236}">
-                <a16:creationId xmlns:a16="http://schemas.microsoft.com/office/drawing/2014/main" id="{6615C9FC-5ABA-FD86-58F6-E8E73E8A7CED}"/>
-              </a:ext>
-            </a:extLst>
-          </p:cNvPr>
+          <p:cNvPr id="6" name="Slide Number Placeholder 5"/>
           <p:cNvSpPr>
             <a:spLocks noGrp="1"/>
           </p:cNvSpPr>
@@ -915,7 +1268,7 @@
           <a:bodyPr/>
           <a:lstStyle/>
           <a:p>
-            <a:fld id="{F32E41F8-49F7-CD4A-BC3D-8F020394F209}" type="slidenum">
+            <a:fld id="{C1FF6DA9-008F-8B48-92A6-B652298478BF}" type="slidenum">
               <a:rPr lang="en-US" smtClean="0"/>
               <a:t>‹#›</a:t>
             </a:fld>
@@ -926,7 +1279,7 @@
     </p:spTree>
     <p:extLst>
       <p:ext uri="{BB962C8B-B14F-4D97-AF65-F5344CB8AC3E}">
-        <p14:creationId xmlns:p14="http://schemas.microsoft.com/office/powerpoint/2010/main" val="1038235598"/>
+        <p14:creationId xmlns:p14="http://schemas.microsoft.com/office/powerpoint/2010/main" val="2614314258"/>
       </p:ext>
     </p:extLst>
   </p:cSld>
@@ -955,13 +1308,7 @@
       </p:grpSpPr>
       <p:sp>
         <p:nvSpPr>
-          <p:cNvPr id="2" name="Title 1">
-            <a:extLst>
-              <a:ext uri="{FF2B5EF4-FFF2-40B4-BE49-F238E27FC236}">
-                <a16:creationId xmlns:a16="http://schemas.microsoft.com/office/drawing/2014/main" id="{C83F4F89-7E29-849E-8226-E89E5088AF41}"/>
-              </a:ext>
-            </a:extLst>
-          </p:cNvPr>
+          <p:cNvPr id="2" name="Title 1"/>
           <p:cNvSpPr>
             <a:spLocks noGrp="1"/>
           </p:cNvSpPr>
@@ -971,136 +1318,131 @@
         </p:nvSpPr>
         <p:spPr>
           <a:xfrm>
-            <a:off x="831850" y="1709738"/>
-            <a:ext cx="10515600" cy="2852737"/>
+            <a:off x="722313" y="4406900"/>
+            <a:ext cx="7772400" cy="1362075"/>
           </a:xfrm>
         </p:spPr>
         <p:txBody>
+          <a:bodyPr anchor="t"/>
+          <a:lstStyle>
+            <a:lvl1pPr algn="l">
+              <a:defRPr sz="4000" b="1" cap="all"/>
+            </a:lvl1pPr>
+          </a:lstStyle>
+          <a:p>
+            <a:r>
+              <a:rPr lang="en-US" smtClean="0"/>
+              <a:t>Click to edit Master title style</a:t>
+            </a:r>
+            <a:endParaRPr lang="en-US"/>
+          </a:p>
+        </p:txBody>
+      </p:sp>
+      <p:sp>
+        <p:nvSpPr>
+          <p:cNvPr id="3" name="Text Placeholder 2"/>
+          <p:cNvSpPr>
+            <a:spLocks noGrp="1"/>
+          </p:cNvSpPr>
+          <p:nvPr>
+            <p:ph type="body" idx="1"/>
+          </p:nvPr>
+        </p:nvSpPr>
+        <p:spPr>
+          <a:xfrm>
+            <a:off x="722313" y="2906713"/>
+            <a:ext cx="7772400" cy="1500187"/>
+          </a:xfrm>
+        </p:spPr>
+        <p:txBody>
           <a:bodyPr anchor="b"/>
           <a:lstStyle>
-            <a:lvl1pPr>
-              <a:defRPr sz="6000"/>
-            </a:lvl1pPr>
-          </a:lstStyle>
-          <a:p>
-            <a:r>
-              <a:rPr lang="en-US"/>
-              <a:t>Click to edit Master title style</a:t>
-            </a:r>
-          </a:p>
-        </p:txBody>
-      </p:sp>
-      <p:sp>
-        <p:nvSpPr>
-          <p:cNvPr id="3" name="Text Placeholder 2">
-            <a:extLst>
-              <a:ext uri="{FF2B5EF4-FFF2-40B4-BE49-F238E27FC236}">
-                <a16:creationId xmlns:a16="http://schemas.microsoft.com/office/drawing/2014/main" id="{8580D751-E361-6657-5554-7D9007B5151A}"/>
-              </a:ext>
-            </a:extLst>
-          </p:cNvPr>
-          <p:cNvSpPr>
-            <a:spLocks noGrp="1"/>
-          </p:cNvSpPr>
-          <p:nvPr>
-            <p:ph type="body" idx="1"/>
-          </p:nvPr>
-        </p:nvSpPr>
-        <p:spPr>
-          <a:xfrm>
-            <a:off x="831850" y="4589463"/>
-            <a:ext cx="10515600" cy="1500187"/>
-          </a:xfrm>
-        </p:spPr>
-        <p:txBody>
-          <a:bodyPr/>
-          <a:lstStyle>
             <a:lvl1pPr marL="0" indent="0">
               <a:buNone/>
-              <a:defRPr sz="2400">
+              <a:defRPr sz="2000">
                 <a:solidFill>
                   <a:schemeClr val="tx1">
-                    <a:tint val="82000"/>
+                    <a:tint val="75000"/>
                   </a:schemeClr>
                 </a:solidFill>
               </a:defRPr>
             </a:lvl1pPr>
             <a:lvl2pPr marL="457200" indent="0">
               <a:buNone/>
-              <a:defRPr sz="2000">
+              <a:defRPr sz="1800">
                 <a:solidFill>
                   <a:schemeClr val="tx1">
-                    <a:tint val="82000"/>
+                    <a:tint val="75000"/>
                   </a:schemeClr>
                 </a:solidFill>
               </a:defRPr>
             </a:lvl2pPr>
             <a:lvl3pPr marL="914400" indent="0">
               <a:buNone/>
-              <a:defRPr sz="1800">
+              <a:defRPr sz="1600">
                 <a:solidFill>
                   <a:schemeClr val="tx1">
-                    <a:tint val="82000"/>
+                    <a:tint val="75000"/>
                   </a:schemeClr>
                 </a:solidFill>
               </a:defRPr>
             </a:lvl3pPr>
             <a:lvl4pPr marL="1371600" indent="0">
               <a:buNone/>
-              <a:defRPr sz="1600">
+              <a:defRPr sz="1400">
                 <a:solidFill>
                   <a:schemeClr val="tx1">
-                    <a:tint val="82000"/>
+                    <a:tint val="75000"/>
                   </a:schemeClr>
                 </a:solidFill>
               </a:defRPr>
             </a:lvl4pPr>
             <a:lvl5pPr marL="1828800" indent="0">
               <a:buNone/>
-              <a:defRPr sz="1600">
+              <a:defRPr sz="1400">
                 <a:solidFill>
                   <a:schemeClr val="tx1">
-                    <a:tint val="82000"/>
+                    <a:tint val="75000"/>
                   </a:schemeClr>
                 </a:solidFill>
               </a:defRPr>
             </a:lvl5pPr>
             <a:lvl6pPr marL="2286000" indent="0">
               <a:buNone/>
-              <a:defRPr sz="1600">
+              <a:defRPr sz="1400">
                 <a:solidFill>
                   <a:schemeClr val="tx1">
-                    <a:tint val="82000"/>
+                    <a:tint val="75000"/>
                   </a:schemeClr>
                 </a:solidFill>
               </a:defRPr>
             </a:lvl6pPr>
             <a:lvl7pPr marL="2743200" indent="0">
               <a:buNone/>
-              <a:defRPr sz="1600">
+              <a:defRPr sz="1400">
                 <a:solidFill>
                   <a:schemeClr val="tx1">
-                    <a:tint val="82000"/>
+                    <a:tint val="75000"/>
                   </a:schemeClr>
                 </a:solidFill>
               </a:defRPr>
             </a:lvl7pPr>
             <a:lvl8pPr marL="3200400" indent="0">
               <a:buNone/>
-              <a:defRPr sz="1600">
+              <a:defRPr sz="1400">
                 <a:solidFill>
                   <a:schemeClr val="tx1">
-                    <a:tint val="82000"/>
+                    <a:tint val="75000"/>
                   </a:schemeClr>
                 </a:solidFill>
               </a:defRPr>
             </a:lvl8pPr>
             <a:lvl9pPr marL="3657600" indent="0">
               <a:buNone/>
-              <a:defRPr sz="1600">
+              <a:defRPr sz="1400">
                 <a:solidFill>
                   <a:schemeClr val="tx1">
-                    <a:tint val="82000"/>
+                    <a:tint val="75000"/>
                   </a:schemeClr>
                 </a:solidFill>
               </a:defRPr>
@@ -1109,7 +1451,7 @@
           <a:p>
             <a:pPr lvl="0"/>
             <a:r>
-              <a:rPr lang="en-US"/>
+              <a:rPr lang="en-US" smtClean="0"/>
               <a:t>Click to edit Master text styles</a:t>
             </a:r>
           </a:p>
@@ -1117,13 +1459,7 @@
       </p:sp>
       <p:sp>
         <p:nvSpPr>
-          <p:cNvPr id="4" name="Date Placeholder 3">
-            <a:extLst>
-              <a:ext uri="{FF2B5EF4-FFF2-40B4-BE49-F238E27FC236}">
-                <a16:creationId xmlns:a16="http://schemas.microsoft.com/office/drawing/2014/main" id="{57730944-57D4-2606-A24E-8925BD873C14}"/>
-              </a:ext>
-            </a:extLst>
-          </p:cNvPr>
+          <p:cNvPr id="4" name="Date Placeholder 3"/>
           <p:cNvSpPr>
             <a:spLocks noGrp="1"/>
           </p:cNvSpPr>
@@ -1136,9 +1472,9 @@
           <a:bodyPr/>
           <a:lstStyle/>
           <a:p>
-            <a:fld id="{22C88FD7-B5A4-B541-9894-CD062EA3E37C}" type="datetimeFigureOut">
-              <a:rPr lang="en-US" smtClean="0"/>
-              <a:t>1/30/26</a:t>
+            <a:fld id="{5BCAD085-E8A6-8845-BD4E-CB4CCA059FC4}" type="datetimeFigureOut">
+              <a:rPr lang="en-US" smtClean="0"/>
+              <a:t>1/27/13</a:t>
             </a:fld>
             <a:endParaRPr lang="en-US"/>
           </a:p>
@@ -1146,13 +1482,7 @@
       </p:sp>
       <p:sp>
         <p:nvSpPr>
-          <p:cNvPr id="5" name="Footer Placeholder 4">
-            <a:extLst>
-              <a:ext uri="{FF2B5EF4-FFF2-40B4-BE49-F238E27FC236}">
-                <a16:creationId xmlns:a16="http://schemas.microsoft.com/office/drawing/2014/main" id="{89513D39-FE8B-9C2E-81D5-651B7C6FC3F0}"/>
-              </a:ext>
-            </a:extLst>
-          </p:cNvPr>
+          <p:cNvPr id="5" name="Footer Placeholder 4"/>
           <p:cNvSpPr>
             <a:spLocks noGrp="1"/>
           </p:cNvSpPr>
@@ -1171,13 +1501,7 @@
       </p:sp>
       <p:sp>
         <p:nvSpPr>
-          <p:cNvPr id="6" name="Slide Number Placeholder 5">
-            <a:extLst>
-              <a:ext uri="{FF2B5EF4-FFF2-40B4-BE49-F238E27FC236}">
-                <a16:creationId xmlns:a16="http://schemas.microsoft.com/office/drawing/2014/main" id="{0503286F-81BF-CC72-ED6D-2D9DD1FACF76}"/>
-              </a:ext>
-            </a:extLst>
-          </p:cNvPr>
+          <p:cNvPr id="6" name="Slide Number Placeholder 5"/>
           <p:cNvSpPr>
             <a:spLocks noGrp="1"/>
           </p:cNvSpPr>
@@ -1190,7 +1514,7 @@
           <a:bodyPr/>
           <a:lstStyle/>
           <a:p>
-            <a:fld id="{F32E41F8-49F7-CD4A-BC3D-8F020394F209}" type="slidenum">
+            <a:fld id="{C1FF6DA9-008F-8B48-92A6-B652298478BF}" type="slidenum">
               <a:rPr lang="en-US" smtClean="0"/>
               <a:t>‹#›</a:t>
             </a:fld>
@@ -1201,7 +1525,7 @@
     </p:spTree>
     <p:extLst>
       <p:ext uri="{BB962C8B-B14F-4D97-AF65-F5344CB8AC3E}">
-        <p14:creationId xmlns:p14="http://schemas.microsoft.com/office/powerpoint/2010/main" val="362732146"/>
+        <p14:creationId xmlns:p14="http://schemas.microsoft.com/office/powerpoint/2010/main" val="960648375"/>
       </p:ext>
     </p:extLst>
   </p:cSld>
@@ -1230,13 +1554,7 @@
       </p:grpSpPr>
       <p:sp>
         <p:nvSpPr>
-          <p:cNvPr id="2" name="Title 1">
-            <a:extLst>
-              <a:ext uri="{FF2B5EF4-FFF2-40B4-BE49-F238E27FC236}">
-                <a16:creationId xmlns:a16="http://schemas.microsoft.com/office/drawing/2014/main" id="{A23D1372-4EBE-BDB5-244C-EBFB89917D4F}"/>
-              </a:ext>
-            </a:extLst>
-          </p:cNvPr>
+          <p:cNvPr id="2" name="Title 1"/>
           <p:cNvSpPr>
             <a:spLocks noGrp="1"/>
           </p:cNvSpPr>
@@ -1250,21 +1568,16 @@
           <a:lstStyle/>
           <a:p>
             <a:r>
-              <a:rPr lang="en-US"/>
+              <a:rPr lang="en-US" smtClean="0"/>
               <a:t>Click to edit Master title style</a:t>
             </a:r>
-          </a:p>
-        </p:txBody>
-      </p:sp>
-      <p:sp>
-        <p:nvSpPr>
-          <p:cNvPr id="3" name="Content Placeholder 2">
-            <a:extLst>
-              <a:ext uri="{FF2B5EF4-FFF2-40B4-BE49-F238E27FC236}">
-                <a16:creationId xmlns:a16="http://schemas.microsoft.com/office/drawing/2014/main" id="{E5B6B890-93C5-41DB-FEA1-60FDDA20ACA0}"/>
-              </a:ext>
-            </a:extLst>
-          </p:cNvPr>
+            <a:endParaRPr lang="en-US"/>
+          </a:p>
+        </p:txBody>
+      </p:sp>
+      <p:sp>
+        <p:nvSpPr>
+          <p:cNvPr id="3" name="Content Placeholder 2"/>
           <p:cNvSpPr>
             <a:spLocks noGrp="1"/>
           </p:cNvSpPr>
@@ -1274,59 +1587,82 @@
         </p:nvSpPr>
         <p:spPr>
           <a:xfrm>
-            <a:off x="838200" y="1825625"/>
-            <a:ext cx="5181600" cy="4351338"/>
+            <a:off x="457200" y="1600200"/>
+            <a:ext cx="4038600" cy="4525963"/>
           </a:xfrm>
         </p:spPr>
         <p:txBody>
           <a:bodyPr/>
-          <a:lstStyle/>
+          <a:lstStyle>
+            <a:lvl1pPr>
+              <a:defRPr sz="2800"/>
+            </a:lvl1pPr>
+            <a:lvl2pPr>
+              <a:defRPr sz="2400"/>
+            </a:lvl2pPr>
+            <a:lvl3pPr>
+              <a:defRPr sz="2000"/>
+            </a:lvl3pPr>
+            <a:lvl4pPr>
+              <a:defRPr sz="1800"/>
+            </a:lvl4pPr>
+            <a:lvl5pPr>
+              <a:defRPr sz="1800"/>
+            </a:lvl5pPr>
+            <a:lvl6pPr>
+              <a:defRPr sz="1800"/>
+            </a:lvl6pPr>
+            <a:lvl7pPr>
+              <a:defRPr sz="1800"/>
+            </a:lvl7pPr>
+            <a:lvl8pPr>
+              <a:defRPr sz="1800"/>
+            </a:lvl8pPr>
+            <a:lvl9pPr>
+              <a:defRPr sz="1800"/>
+            </a:lvl9pPr>
+          </a:lstStyle>
           <a:p>
             <a:pPr lvl="0"/>
             <a:r>
-              <a:rPr lang="en-US"/>
+              <a:rPr lang="en-US" smtClean="0"/>
               <a:t>Click to edit Master text styles</a:t>
             </a:r>
           </a:p>
           <a:p>
             <a:pPr lvl="1"/>
             <a:r>
-              <a:rPr lang="en-US"/>
+              <a:rPr lang="en-US" smtClean="0"/>
               <a:t>Second level</a:t>
             </a:r>
           </a:p>
           <a:p>
             <a:pPr lvl="2"/>
             <a:r>
-              <a:rPr lang="en-US"/>
+              <a:rPr lang="en-US" smtClean="0"/>
               <a:t>Third level</a:t>
             </a:r>
           </a:p>
           <a:p>
             <a:pPr lvl="3"/>
             <a:r>
-              <a:rPr lang="en-US"/>
+              <a:rPr lang="en-US" smtClean="0"/>
               <a:t>Fourth level</a:t>
             </a:r>
           </a:p>
           <a:p>
             <a:pPr lvl="4"/>
             <a:r>
-              <a:rPr lang="en-US"/>
+              <a:rPr lang="en-US" smtClean="0"/>
               <a:t>Fifth level</a:t>
             </a:r>
-          </a:p>
-        </p:txBody>
-      </p:sp>
-      <p:sp>
-        <p:nvSpPr>
-          <p:cNvPr id="4" name="Content Placeholder 3">
-            <a:extLst>
-              <a:ext uri="{FF2B5EF4-FFF2-40B4-BE49-F238E27FC236}">
-                <a16:creationId xmlns:a16="http://schemas.microsoft.com/office/drawing/2014/main" id="{A475A576-A502-D8E1-56E7-C8CFCC1FE9B1}"/>
-              </a:ext>
-            </a:extLst>
-          </p:cNvPr>
+            <a:endParaRPr lang="en-US"/>
+          </a:p>
+        </p:txBody>
+      </p:sp>
+      <p:sp>
+        <p:nvSpPr>
+          <p:cNvPr id="4" name="Content Placeholder 3"/>
           <p:cNvSpPr>
             <a:spLocks noGrp="1"/>
           </p:cNvSpPr>
@@ -1336,59 +1672,82 @@
         </p:nvSpPr>
         <p:spPr>
           <a:xfrm>
-            <a:off x="6172200" y="1825625"/>
-            <a:ext cx="5181600" cy="4351338"/>
+            <a:off x="4648200" y="1600200"/>
+            <a:ext cx="4038600" cy="4525963"/>
           </a:xfrm>
         </p:spPr>
         <p:txBody>
           <a:bodyPr/>
-          <a:lstStyle/>
+          <a:lstStyle>
+            <a:lvl1pPr>
+              <a:defRPr sz="2800"/>
+            </a:lvl1pPr>
+            <a:lvl2pPr>
+              <a:defRPr sz="2400"/>
+            </a:lvl2pPr>
+            <a:lvl3pPr>
+              <a:defRPr sz="2000"/>
+            </a:lvl3pPr>
+            <a:lvl4pPr>
+              <a:defRPr sz="1800"/>
+            </a:lvl4pPr>
+            <a:lvl5pPr>
+              <a:defRPr sz="1800"/>
+            </a:lvl5pPr>
+            <a:lvl6pPr>
+              <a:defRPr sz="1800"/>
+            </a:lvl6pPr>
+            <a:lvl7pPr>
+              <a:defRPr sz="1800"/>
+            </a:lvl7pPr>
+            <a:lvl8pPr>
+              <a:defRPr sz="1800"/>
+            </a:lvl8pPr>
+            <a:lvl9pPr>
+              <a:defRPr sz="1800"/>
+            </a:lvl9pPr>
+          </a:lstStyle>
           <a:p>
             <a:pPr lvl="0"/>
             <a:r>
-              <a:rPr lang="en-US"/>
+              <a:rPr lang="en-US" smtClean="0"/>
               <a:t>Click to edit Master text styles</a:t>
             </a:r>
           </a:p>
           <a:p>
             <a:pPr lvl="1"/>
             <a:r>
-              <a:rPr lang="en-US"/>
+              <a:rPr lang="en-US" smtClean="0"/>
               <a:t>Second level</a:t>
             </a:r>
           </a:p>
           <a:p>
             <a:pPr lvl="2"/>
             <a:r>
-              <a:rPr lang="en-US"/>
+              <a:rPr lang="en-US" smtClean="0"/>
               <a:t>Third level</a:t>
             </a:r>
           </a:p>
           <a:p>
             <a:pPr lvl="3"/>
             <a:r>
-              <a:rPr lang="en-US"/>
+              <a:rPr lang="en-US" smtClean="0"/>
               <a:t>Fourth level</a:t>
             </a:r>
           </a:p>
           <a:p>
             <a:pPr lvl="4"/>
             <a:r>
-              <a:rPr lang="en-US"/>
+              <a:rPr lang="en-US" smtClean="0"/>
               <a:t>Fifth level</a:t>
             </a:r>
-          </a:p>
-        </p:txBody>
-      </p:sp>
-      <p:sp>
-        <p:nvSpPr>
-          <p:cNvPr id="5" name="Date Placeholder 4">
-            <a:extLst>
-              <a:ext uri="{FF2B5EF4-FFF2-40B4-BE49-F238E27FC236}">
-                <a16:creationId xmlns:a16="http://schemas.microsoft.com/office/drawing/2014/main" id="{A053C70F-0229-E7F6-799B-A9E3AB287D5A}"/>
-              </a:ext>
-            </a:extLst>
-          </p:cNvPr>
+            <a:endParaRPr lang="en-US"/>
+          </a:p>
+        </p:txBody>
+      </p:sp>
+      <p:sp>
+        <p:nvSpPr>
+          <p:cNvPr id="5" name="Date Placeholder 4"/>
           <p:cNvSpPr>
             <a:spLocks noGrp="1"/>
           </p:cNvSpPr>
@@ -1401,9 +1760,9 @@
           <a:bodyPr/>
           <a:lstStyle/>
           <a:p>
-            <a:fld id="{22C88FD7-B5A4-B541-9894-CD062EA3E37C}" type="datetimeFigureOut">
-              <a:rPr lang="en-US" smtClean="0"/>
-              <a:t>1/30/26</a:t>
+            <a:fld id="{5BCAD085-E8A6-8845-BD4E-CB4CCA059FC4}" type="datetimeFigureOut">
+              <a:rPr lang="en-US" smtClean="0"/>
+              <a:t>1/27/13</a:t>
             </a:fld>
             <a:endParaRPr lang="en-US"/>
           </a:p>
@@ -1411,13 +1770,7 @@
       </p:sp>
       <p:sp>
         <p:nvSpPr>
-          <p:cNvPr id="6" name="Footer Placeholder 5">
-            <a:extLst>
-              <a:ext uri="{FF2B5EF4-FFF2-40B4-BE49-F238E27FC236}">
-                <a16:creationId xmlns:a16="http://schemas.microsoft.com/office/drawing/2014/main" id="{CB8298EA-0B9F-1253-8DB1-E1EBC5EC35E7}"/>
-              </a:ext>
-            </a:extLst>
-          </p:cNvPr>
+          <p:cNvPr id="6" name="Footer Placeholder 5"/>
           <p:cNvSpPr>
             <a:spLocks noGrp="1"/>
           </p:cNvSpPr>
@@ -1436,13 +1789,7 @@
       </p:sp>
       <p:sp>
         <p:nvSpPr>
-          <p:cNvPr id="7" name="Slide Number Placeholder 6">
-            <a:extLst>
-              <a:ext uri="{FF2B5EF4-FFF2-40B4-BE49-F238E27FC236}">
-                <a16:creationId xmlns:a16="http://schemas.microsoft.com/office/drawing/2014/main" id="{A8D68357-987A-6385-5075-93F4D81517DD}"/>
-              </a:ext>
-            </a:extLst>
-          </p:cNvPr>
+          <p:cNvPr id="7" name="Slide Number Placeholder 6"/>
           <p:cNvSpPr>
             <a:spLocks noGrp="1"/>
           </p:cNvSpPr>
@@ -1455,7 +1802,7 @@
           <a:bodyPr/>
           <a:lstStyle/>
           <a:p>
-            <a:fld id="{F32E41F8-49F7-CD4A-BC3D-8F020394F209}" type="slidenum">
+            <a:fld id="{C1FF6DA9-008F-8B48-92A6-B652298478BF}" type="slidenum">
               <a:rPr lang="en-US" smtClean="0"/>
               <a:t>‹#›</a:t>
             </a:fld>
@@ -1466,7 +1813,7 @@
     </p:spTree>
     <p:extLst>
       <p:ext uri="{BB962C8B-B14F-4D97-AF65-F5344CB8AC3E}">
-        <p14:creationId xmlns:p14="http://schemas.microsoft.com/office/powerpoint/2010/main" val="1730884687"/>
+        <p14:creationId xmlns:p14="http://schemas.microsoft.com/office/powerpoint/2010/main" val="2782244947"/>
       </p:ext>
     </p:extLst>
   </p:cSld>
@@ -1495,57 +1842,45 @@
       </p:grpSpPr>
       <p:sp>
         <p:nvSpPr>
-          <p:cNvPr id="2" name="Title 1">
-            <a:extLst>
-              <a:ext uri="{FF2B5EF4-FFF2-40B4-BE49-F238E27FC236}">
-                <a16:creationId xmlns:a16="http://schemas.microsoft.com/office/drawing/2014/main" id="{0FA2B1CB-FE7F-1D8C-6723-A3EF62A13D05}"/>
-              </a:ext>
-            </a:extLst>
-          </p:cNvPr>
+          <p:cNvPr id="2" name="Title 1"/>
           <p:cNvSpPr>
             <a:spLocks noGrp="1"/>
           </p:cNvSpPr>
           <p:nvPr>
             <p:ph type="title"/>
+          </p:nvPr>
+        </p:nvSpPr>
+        <p:spPr/>
+        <p:txBody>
+          <a:bodyPr/>
+          <a:lstStyle>
+            <a:lvl1pPr>
+              <a:defRPr/>
+            </a:lvl1pPr>
+          </a:lstStyle>
+          <a:p>
+            <a:r>
+              <a:rPr lang="en-US" smtClean="0"/>
+              <a:t>Click to edit Master title style</a:t>
+            </a:r>
+            <a:endParaRPr lang="en-US"/>
+          </a:p>
+        </p:txBody>
+      </p:sp>
+      <p:sp>
+        <p:nvSpPr>
+          <p:cNvPr id="3" name="Text Placeholder 2"/>
+          <p:cNvSpPr>
+            <a:spLocks noGrp="1"/>
+          </p:cNvSpPr>
+          <p:nvPr>
+            <p:ph type="body" idx="1"/>
           </p:nvPr>
         </p:nvSpPr>
         <p:spPr>
           <a:xfrm>
-            <a:off x="839788" y="365125"/>
-            <a:ext cx="10515600" cy="1325563"/>
-          </a:xfrm>
-        </p:spPr>
-        <p:txBody>
-          <a:bodyPr/>
-          <a:lstStyle/>
-          <a:p>
-            <a:r>
-              <a:rPr lang="en-US"/>
-              <a:t>Click to edit Master title style</a:t>
-            </a:r>
-          </a:p>
-        </p:txBody>
-      </p:sp>
-      <p:sp>
-        <p:nvSpPr>
-          <p:cNvPr id="3" name="Text Placeholder 2">
-            <a:extLst>
-              <a:ext uri="{FF2B5EF4-FFF2-40B4-BE49-F238E27FC236}">
-                <a16:creationId xmlns:a16="http://schemas.microsoft.com/office/drawing/2014/main" id="{2394AFDD-7457-6367-B4C3-78460971E24F}"/>
-              </a:ext>
-            </a:extLst>
-          </p:cNvPr>
-          <p:cNvSpPr>
-            <a:spLocks noGrp="1"/>
-          </p:cNvSpPr>
-          <p:nvPr>
-            <p:ph type="body" idx="1"/>
-          </p:nvPr>
-        </p:nvSpPr>
-        <p:spPr>
-          <a:xfrm>
-            <a:off x="839788" y="1681163"/>
-            <a:ext cx="5157787" cy="823912"/>
+            <a:off x="457200" y="1535113"/>
+            <a:ext cx="4040188" cy="639762"/>
           </a:xfrm>
         </p:spPr>
         <p:txBody>
@@ -1591,7 +1926,7 @@
           <a:p>
             <a:pPr lvl="0"/>
             <a:r>
-              <a:rPr lang="en-US"/>
+              <a:rPr lang="en-US" smtClean="0"/>
               <a:t>Click to edit Master text styles</a:t>
             </a:r>
           </a:p>
@@ -1599,13 +1934,7 @@
       </p:sp>
       <p:sp>
         <p:nvSpPr>
-          <p:cNvPr id="4" name="Content Placeholder 3">
-            <a:extLst>
-              <a:ext uri="{FF2B5EF4-FFF2-40B4-BE49-F238E27FC236}">
-                <a16:creationId xmlns:a16="http://schemas.microsoft.com/office/drawing/2014/main" id="{CA4B0CBB-A954-843A-DACB-766E4F3AFDBE}"/>
-              </a:ext>
-            </a:extLst>
-          </p:cNvPr>
+          <p:cNvPr id="4" name="Content Placeholder 3"/>
           <p:cNvSpPr>
             <a:spLocks noGrp="1"/>
           </p:cNvSpPr>
@@ -1615,59 +1944,82 @@
         </p:nvSpPr>
         <p:spPr>
           <a:xfrm>
-            <a:off x="839788" y="2505075"/>
-            <a:ext cx="5157787" cy="3684588"/>
+            <a:off x="457200" y="2174875"/>
+            <a:ext cx="4040188" cy="3951288"/>
           </a:xfrm>
         </p:spPr>
         <p:txBody>
           <a:bodyPr/>
-          <a:lstStyle/>
+          <a:lstStyle>
+            <a:lvl1pPr>
+              <a:defRPr sz="2400"/>
+            </a:lvl1pPr>
+            <a:lvl2pPr>
+              <a:defRPr sz="2000"/>
+            </a:lvl2pPr>
+            <a:lvl3pPr>
+              <a:defRPr sz="1800"/>
+            </a:lvl3pPr>
+            <a:lvl4pPr>
+              <a:defRPr sz="1600"/>
+            </a:lvl4pPr>
+            <a:lvl5pPr>
+              <a:defRPr sz="1600"/>
+            </a:lvl5pPr>
+            <a:lvl6pPr>
+              <a:defRPr sz="1600"/>
+            </a:lvl6pPr>
+            <a:lvl7pPr>
+              <a:defRPr sz="1600"/>
+            </a:lvl7pPr>
+            <a:lvl8pPr>
+              <a:defRPr sz="1600"/>
+            </a:lvl8pPr>
+            <a:lvl9pPr>
+              <a:defRPr sz="1600"/>
+            </a:lvl9pPr>
+          </a:lstStyle>
           <a:p>
             <a:pPr lvl="0"/>
             <a:r>
-              <a:rPr lang="en-US"/>
+              <a:rPr lang="en-US" smtClean="0"/>
               <a:t>Click to edit Master text styles</a:t>
             </a:r>
           </a:p>
           <a:p>
             <a:pPr lvl="1"/>
             <a:r>
-              <a:rPr lang="en-US"/>
+              <a:rPr lang="en-US" smtClean="0"/>
               <a:t>Second level</a:t>
             </a:r>
           </a:p>
           <a:p>
             <a:pPr lvl="2"/>
             <a:r>
-              <a:rPr lang="en-US"/>
+              <a:rPr lang="en-US" smtClean="0"/>
               <a:t>Third level</a:t>
             </a:r>
           </a:p>
           <a:p>
             <a:pPr lvl="3"/>
             <a:r>
-              <a:rPr lang="en-US"/>
+              <a:rPr lang="en-US" smtClean="0"/>
               <a:t>Fourth level</a:t>
             </a:r>
           </a:p>
           <a:p>
             <a:pPr lvl="4"/>
             <a:r>
-              <a:rPr lang="en-US"/>
+              <a:rPr lang="en-US" smtClean="0"/>
               <a:t>Fifth level</a:t>
             </a:r>
-          </a:p>
-        </p:txBody>
-      </p:sp>
-      <p:sp>
-        <p:nvSpPr>
-          <p:cNvPr id="5" name="Text Placeholder 4">
-            <a:extLst>
-              <a:ext uri="{FF2B5EF4-FFF2-40B4-BE49-F238E27FC236}">
-                <a16:creationId xmlns:a16="http://schemas.microsoft.com/office/drawing/2014/main" id="{4DC4E0D0-64E9-D1C8-5C09-BBACD50775F7}"/>
-              </a:ext>
-            </a:extLst>
-          </p:cNvPr>
+            <a:endParaRPr lang="en-US"/>
+          </a:p>
+        </p:txBody>
+      </p:sp>
+      <p:sp>
+        <p:nvSpPr>
+          <p:cNvPr id="5" name="Text Placeholder 4"/>
           <p:cNvSpPr>
             <a:spLocks noGrp="1"/>
           </p:cNvSpPr>
@@ -1677,8 +2029,8 @@
         </p:nvSpPr>
         <p:spPr>
           <a:xfrm>
-            <a:off x="6172200" y="1681163"/>
-            <a:ext cx="5183188" cy="823912"/>
+            <a:off x="4645025" y="1535113"/>
+            <a:ext cx="4041775" cy="639762"/>
           </a:xfrm>
         </p:spPr>
         <p:txBody>
@@ -1724,7 +2076,7 @@
           <a:p>
             <a:pPr lvl="0"/>
             <a:r>
-              <a:rPr lang="en-US"/>
+              <a:rPr lang="en-US" smtClean="0"/>
               <a:t>Click to edit Master text styles</a:t>
             </a:r>
           </a:p>
@@ -1732,13 +2084,7 @@
       </p:sp>
       <p:sp>
         <p:nvSpPr>
-          <p:cNvPr id="6" name="Content Placeholder 5">
-            <a:extLst>
-              <a:ext uri="{FF2B5EF4-FFF2-40B4-BE49-F238E27FC236}">
-                <a16:creationId xmlns:a16="http://schemas.microsoft.com/office/drawing/2014/main" id="{8B838428-0EBA-EDFF-B00B-F3FB4FDF5354}"/>
-              </a:ext>
-            </a:extLst>
-          </p:cNvPr>
+          <p:cNvPr id="6" name="Content Placeholder 5"/>
           <p:cNvSpPr>
             <a:spLocks noGrp="1"/>
           </p:cNvSpPr>
@@ -1748,59 +2094,82 @@
         </p:nvSpPr>
         <p:spPr>
           <a:xfrm>
-            <a:off x="6172200" y="2505075"/>
-            <a:ext cx="5183188" cy="3684588"/>
+            <a:off x="4645025" y="2174875"/>
+            <a:ext cx="4041775" cy="3951288"/>
           </a:xfrm>
         </p:spPr>
         <p:txBody>
           <a:bodyPr/>
-          <a:lstStyle/>
+          <a:lstStyle>
+            <a:lvl1pPr>
+              <a:defRPr sz="2400"/>
+            </a:lvl1pPr>
+            <a:lvl2pPr>
+              <a:defRPr sz="2000"/>
+            </a:lvl2pPr>
+            <a:lvl3pPr>
+              <a:defRPr sz="1800"/>
+            </a:lvl3pPr>
+            <a:lvl4pPr>
+              <a:defRPr sz="1600"/>
+            </a:lvl4pPr>
+            <a:lvl5pPr>
+              <a:defRPr sz="1600"/>
+            </a:lvl5pPr>
+            <a:lvl6pPr>
+              <a:defRPr sz="1600"/>
+            </a:lvl6pPr>
+            <a:lvl7pPr>
+              <a:defRPr sz="1600"/>
+            </a:lvl7pPr>
+            <a:lvl8pPr>
+              <a:defRPr sz="1600"/>
+            </a:lvl8pPr>
+            <a:lvl9pPr>
+              <a:defRPr sz="1600"/>
+            </a:lvl9pPr>
+          </a:lstStyle>
           <a:p>
             <a:pPr lvl="0"/>
             <a:r>
-              <a:rPr lang="en-US"/>
+              <a:rPr lang="en-US" smtClean="0"/>
               <a:t>Click to edit Master text styles</a:t>
             </a:r>
           </a:p>
           <a:p>
             <a:pPr lvl="1"/>
             <a:r>
-              <a:rPr lang="en-US"/>
+              <a:rPr lang="en-US" smtClean="0"/>
               <a:t>Second level</a:t>
             </a:r>
           </a:p>
           <a:p>
             <a:pPr lvl="2"/>
             <a:r>
-              <a:rPr lang="en-US"/>
+              <a:rPr lang="en-US" smtClean="0"/>
               <a:t>Third level</a:t>
             </a:r>
           </a:p>
           <a:p>
             <a:pPr lvl="3"/>
             <a:r>
-              <a:rPr lang="en-US"/>
+              <a:rPr lang="en-US" smtClean="0"/>
               <a:t>Fourth level</a:t>
             </a:r>
           </a:p>
           <a:p>
             <a:pPr lvl="4"/>
             <a:r>
-              <a:rPr lang="en-US"/>
+              <a:rPr lang="en-US" smtClean="0"/>
               <a:t>Fifth level</a:t>
             </a:r>
-          </a:p>
-        </p:txBody>
-      </p:sp>
-      <p:sp>
-        <p:nvSpPr>
-          <p:cNvPr id="7" name="Date Placeholder 6">
-            <a:extLst>
-              <a:ext uri="{FF2B5EF4-FFF2-40B4-BE49-F238E27FC236}">
-                <a16:creationId xmlns:a16="http://schemas.microsoft.com/office/drawing/2014/main" id="{E071A537-ED4F-ED94-0D92-2EA7CBBFF596}"/>
-              </a:ext>
-            </a:extLst>
-          </p:cNvPr>
+            <a:endParaRPr lang="en-US"/>
+          </a:p>
+        </p:txBody>
+      </p:sp>
+      <p:sp>
+        <p:nvSpPr>
+          <p:cNvPr id="7" name="Date Placeholder 6"/>
           <p:cNvSpPr>
             <a:spLocks noGrp="1"/>
           </p:cNvSpPr>
@@ -1813,9 +2182,9 @@
           <a:bodyPr/>
           <a:lstStyle/>
           <a:p>
-            <a:fld id="{22C88FD7-B5A4-B541-9894-CD062EA3E37C}" type="datetimeFigureOut">
-              <a:rPr lang="en-US" smtClean="0"/>
-              <a:t>1/30/26</a:t>
+            <a:fld id="{5BCAD085-E8A6-8845-BD4E-CB4CCA059FC4}" type="datetimeFigureOut">
+              <a:rPr lang="en-US" smtClean="0"/>
+              <a:t>1/27/13</a:t>
             </a:fld>
             <a:endParaRPr lang="en-US"/>
           </a:p>
@@ -1823,13 +2192,7 @@
       </p:sp>
       <p:sp>
         <p:nvSpPr>
-          <p:cNvPr id="8" name="Footer Placeholder 7">
-            <a:extLst>
-              <a:ext uri="{FF2B5EF4-FFF2-40B4-BE49-F238E27FC236}">
-                <a16:creationId xmlns:a16="http://schemas.microsoft.com/office/drawing/2014/main" id="{F4C2C70A-588D-A17F-F6D4-B411984D0B57}"/>
-              </a:ext>
-            </a:extLst>
-          </p:cNvPr>
+          <p:cNvPr id="8" name="Footer Placeholder 7"/>
           <p:cNvSpPr>
             <a:spLocks noGrp="1"/>
           </p:cNvSpPr>
@@ -1848,13 +2211,7 @@
       </p:sp>
       <p:sp>
         <p:nvSpPr>
-          <p:cNvPr id="9" name="Slide Number Placeholder 8">
-            <a:extLst>
-              <a:ext uri="{FF2B5EF4-FFF2-40B4-BE49-F238E27FC236}">
-                <a16:creationId xmlns:a16="http://schemas.microsoft.com/office/drawing/2014/main" id="{2AAAD3C8-ACC7-C096-87DA-9DAF3335E1BF}"/>
-              </a:ext>
-            </a:extLst>
-          </p:cNvPr>
+          <p:cNvPr id="9" name="Slide Number Placeholder 8"/>
           <p:cNvSpPr>
             <a:spLocks noGrp="1"/>
           </p:cNvSpPr>
@@ -1867,7 +2224,7 @@
           <a:bodyPr/>
           <a:lstStyle/>
           <a:p>
-            <a:fld id="{F32E41F8-49F7-CD4A-BC3D-8F020394F209}" type="slidenum">
+            <a:fld id="{C1FF6DA9-008F-8B48-92A6-B652298478BF}" type="slidenum">
               <a:rPr lang="en-US" smtClean="0"/>
               <a:t>‹#›</a:t>
             </a:fld>
@@ -1878,7 +2235,7 @@
     </p:spTree>
     <p:extLst>
       <p:ext uri="{BB962C8B-B14F-4D97-AF65-F5344CB8AC3E}">
-        <p14:creationId xmlns:p14="http://schemas.microsoft.com/office/powerpoint/2010/main" val="543160650"/>
+        <p14:creationId xmlns:p14="http://schemas.microsoft.com/office/powerpoint/2010/main" val="990158736"/>
       </p:ext>
     </p:extLst>
   </p:cSld>
@@ -1907,13 +2264,7 @@
       </p:grpSpPr>
       <p:sp>
         <p:nvSpPr>
-          <p:cNvPr id="2" name="Title 1">
-            <a:extLst>
-              <a:ext uri="{FF2B5EF4-FFF2-40B4-BE49-F238E27FC236}">
-                <a16:creationId xmlns:a16="http://schemas.microsoft.com/office/drawing/2014/main" id="{18A9DBB1-CB5C-ED9D-AFA6-1002C98BF954}"/>
-              </a:ext>
-            </a:extLst>
-          </p:cNvPr>
+          <p:cNvPr id="2" name="Title 1"/>
           <p:cNvSpPr>
             <a:spLocks noGrp="1"/>
           </p:cNvSpPr>
@@ -1927,21 +2278,16 @@
           <a:lstStyle/>
           <a:p>
             <a:r>
-              <a:rPr lang="en-US"/>
+              <a:rPr lang="en-US" smtClean="0"/>
               <a:t>Click to edit Master title style</a:t>
             </a:r>
-          </a:p>
-        </p:txBody>
-      </p:sp>
-      <p:sp>
-        <p:nvSpPr>
-          <p:cNvPr id="3" name="Date Placeholder 2">
-            <a:extLst>
-              <a:ext uri="{FF2B5EF4-FFF2-40B4-BE49-F238E27FC236}">
-                <a16:creationId xmlns:a16="http://schemas.microsoft.com/office/drawing/2014/main" id="{A8EA3E02-200D-A927-1A47-C5A4A9FA38AF}"/>
-              </a:ext>
-            </a:extLst>
-          </p:cNvPr>
+            <a:endParaRPr lang="en-US"/>
+          </a:p>
+        </p:txBody>
+      </p:sp>
+      <p:sp>
+        <p:nvSpPr>
+          <p:cNvPr id="3" name="Date Placeholder 2"/>
           <p:cNvSpPr>
             <a:spLocks noGrp="1"/>
           </p:cNvSpPr>
@@ -1954,9 +2300,9 @@
           <a:bodyPr/>
           <a:lstStyle/>
           <a:p>
-            <a:fld id="{22C88FD7-B5A4-B541-9894-CD062EA3E37C}" type="datetimeFigureOut">
-              <a:rPr lang="en-US" smtClean="0"/>
-              <a:t>1/30/26</a:t>
+            <a:fld id="{5BCAD085-E8A6-8845-BD4E-CB4CCA059FC4}" type="datetimeFigureOut">
+              <a:rPr lang="en-US" smtClean="0"/>
+              <a:t>1/27/13</a:t>
             </a:fld>
             <a:endParaRPr lang="en-US"/>
           </a:p>
@@ -1964,13 +2310,7 @@
       </p:sp>
       <p:sp>
         <p:nvSpPr>
-          <p:cNvPr id="4" name="Footer Placeholder 3">
-            <a:extLst>
-              <a:ext uri="{FF2B5EF4-FFF2-40B4-BE49-F238E27FC236}">
-                <a16:creationId xmlns:a16="http://schemas.microsoft.com/office/drawing/2014/main" id="{8FD118E4-8C49-B31E-CAA5-6A1271D4F19A}"/>
-              </a:ext>
-            </a:extLst>
-          </p:cNvPr>
+          <p:cNvPr id="4" name="Footer Placeholder 3"/>
           <p:cNvSpPr>
             <a:spLocks noGrp="1"/>
           </p:cNvSpPr>
@@ -1989,13 +2329,7 @@
       </p:sp>
       <p:sp>
         <p:nvSpPr>
-          <p:cNvPr id="5" name="Slide Number Placeholder 4">
-            <a:extLst>
-              <a:ext uri="{FF2B5EF4-FFF2-40B4-BE49-F238E27FC236}">
-                <a16:creationId xmlns:a16="http://schemas.microsoft.com/office/drawing/2014/main" id="{8FEBB173-5F4C-84EA-E2C3-87DA65A78B24}"/>
-              </a:ext>
-            </a:extLst>
-          </p:cNvPr>
+          <p:cNvPr id="5" name="Slide Number Placeholder 4"/>
           <p:cNvSpPr>
             <a:spLocks noGrp="1"/>
           </p:cNvSpPr>
@@ -2008,7 +2342,7 @@
           <a:bodyPr/>
           <a:lstStyle/>
           <a:p>
-            <a:fld id="{F32E41F8-49F7-CD4A-BC3D-8F020394F209}" type="slidenum">
+            <a:fld id="{C1FF6DA9-008F-8B48-92A6-B652298478BF}" type="slidenum">
               <a:rPr lang="en-US" smtClean="0"/>
               <a:t>‹#›</a:t>
             </a:fld>
@@ -2019,7 +2353,7 @@
     </p:spTree>
     <p:extLst>
       <p:ext uri="{BB962C8B-B14F-4D97-AF65-F5344CB8AC3E}">
-        <p14:creationId xmlns:p14="http://schemas.microsoft.com/office/powerpoint/2010/main" val="3218112065"/>
+        <p14:creationId xmlns:p14="http://schemas.microsoft.com/office/powerpoint/2010/main" val="727027711"/>
       </p:ext>
     </p:extLst>
   </p:cSld>
@@ -2048,13 +2382,7 @@
       </p:grpSpPr>
       <p:sp>
         <p:nvSpPr>
-          <p:cNvPr id="2" name="Date Placeholder 1">
-            <a:extLst>
-              <a:ext uri="{FF2B5EF4-FFF2-40B4-BE49-F238E27FC236}">
-                <a16:creationId xmlns:a16="http://schemas.microsoft.com/office/drawing/2014/main" id="{E7E66649-96F3-319D-455B-0D92EBECBAD7}"/>
-              </a:ext>
-            </a:extLst>
-          </p:cNvPr>
+          <p:cNvPr id="2" name="Date Placeholder 1"/>
           <p:cNvSpPr>
             <a:spLocks noGrp="1"/>
           </p:cNvSpPr>
@@ -2067,9 +2395,9 @@
           <a:bodyPr/>
           <a:lstStyle/>
           <a:p>
-            <a:fld id="{22C88FD7-B5A4-B541-9894-CD062EA3E37C}" type="datetimeFigureOut">
-              <a:rPr lang="en-US" smtClean="0"/>
-              <a:t>1/30/26</a:t>
+            <a:fld id="{5BCAD085-E8A6-8845-BD4E-CB4CCA059FC4}" type="datetimeFigureOut">
+              <a:rPr lang="en-US" smtClean="0"/>
+              <a:t>1/27/13</a:t>
             </a:fld>
             <a:endParaRPr lang="en-US"/>
           </a:p>
@@ -2077,13 +2405,7 @@
       </p:sp>
       <p:sp>
         <p:nvSpPr>
-          <p:cNvPr id="3" name="Footer Placeholder 2">
-            <a:extLst>
-              <a:ext uri="{FF2B5EF4-FFF2-40B4-BE49-F238E27FC236}">
-                <a16:creationId xmlns:a16="http://schemas.microsoft.com/office/drawing/2014/main" id="{58C330A5-0428-1014-8BDB-68FDC0EE983C}"/>
-              </a:ext>
-            </a:extLst>
-          </p:cNvPr>
+          <p:cNvPr id="3" name="Footer Placeholder 2"/>
           <p:cNvSpPr>
             <a:spLocks noGrp="1"/>
           </p:cNvSpPr>
@@ -2102,13 +2424,7 @@
       </p:sp>
       <p:sp>
         <p:nvSpPr>
-          <p:cNvPr id="4" name="Slide Number Placeholder 3">
-            <a:extLst>
-              <a:ext uri="{FF2B5EF4-FFF2-40B4-BE49-F238E27FC236}">
-                <a16:creationId xmlns:a16="http://schemas.microsoft.com/office/drawing/2014/main" id="{3FE8FEF7-A13A-E16C-C232-FE126EC24EA1}"/>
-              </a:ext>
-            </a:extLst>
-          </p:cNvPr>
+          <p:cNvPr id="4" name="Slide Number Placeholder 3"/>
           <p:cNvSpPr>
             <a:spLocks noGrp="1"/>
           </p:cNvSpPr>
@@ -2121,7 +2437,7 @@
           <a:bodyPr/>
           <a:lstStyle/>
           <a:p>
-            <a:fld id="{F32E41F8-49F7-CD4A-BC3D-8F020394F209}" type="slidenum">
+            <a:fld id="{C1FF6DA9-008F-8B48-92A6-B652298478BF}" type="slidenum">
               <a:rPr lang="en-US" smtClean="0"/>
               <a:t>‹#›</a:t>
             </a:fld>
@@ -2132,7 +2448,7 @@
     </p:spTree>
     <p:extLst>
       <p:ext uri="{BB962C8B-B14F-4D97-AF65-F5344CB8AC3E}">
-        <p14:creationId xmlns:p14="http://schemas.microsoft.com/office/powerpoint/2010/main" val="2956770079"/>
+        <p14:creationId xmlns:p14="http://schemas.microsoft.com/office/powerpoint/2010/main" val="1212999818"/>
       </p:ext>
     </p:extLst>
   </p:cSld>
@@ -2161,13 +2477,7 @@
       </p:grpSpPr>
       <p:sp>
         <p:nvSpPr>
-          <p:cNvPr id="2" name="Title 1">
-            <a:extLst>
-              <a:ext uri="{FF2B5EF4-FFF2-40B4-BE49-F238E27FC236}">
-                <a16:creationId xmlns:a16="http://schemas.microsoft.com/office/drawing/2014/main" id="{8B7972E3-E5CE-C2D3-135D-3DD2FB38922E}"/>
-              </a:ext>
-            </a:extLst>
-          </p:cNvPr>
+          <p:cNvPr id="2" name="Title 1"/>
           <p:cNvSpPr>
             <a:spLocks noGrp="1"/>
           </p:cNvSpPr>
@@ -2177,34 +2487,29 @@
         </p:nvSpPr>
         <p:spPr>
           <a:xfrm>
-            <a:off x="839788" y="457200"/>
-            <a:ext cx="3932237" cy="1600200"/>
+            <a:off x="457200" y="273050"/>
+            <a:ext cx="3008313" cy="1162050"/>
           </a:xfrm>
         </p:spPr>
         <p:txBody>
           <a:bodyPr anchor="b"/>
           <a:lstStyle>
-            <a:lvl1pPr>
-              <a:defRPr sz="3200"/>
+            <a:lvl1pPr algn="l">
+              <a:defRPr sz="2000" b="1"/>
             </a:lvl1pPr>
           </a:lstStyle>
           <a:p>
             <a:r>
-              <a:rPr lang="en-US"/>
+              <a:rPr lang="en-US" smtClean="0"/>
               <a:t>Click to edit Master title style</a:t>
             </a:r>
-          </a:p>
-        </p:txBody>
-      </p:sp>
-      <p:sp>
-        <p:nvSpPr>
-          <p:cNvPr id="3" name="Content Placeholder 2">
-            <a:extLst>
-              <a:ext uri="{FF2B5EF4-FFF2-40B4-BE49-F238E27FC236}">
-                <a16:creationId xmlns:a16="http://schemas.microsoft.com/office/drawing/2014/main" id="{C434363F-8E15-45E3-E4A4-DD877FFB009D}"/>
-              </a:ext>
-            </a:extLst>
-          </p:cNvPr>
+            <a:endParaRPr lang="en-US"/>
+          </a:p>
+        </p:txBody>
+      </p:sp>
+      <p:sp>
+        <p:nvSpPr>
+          <p:cNvPr id="3" name="Content Placeholder 2"/>
           <p:cNvSpPr>
             <a:spLocks noGrp="1"/>
           </p:cNvSpPr>
@@ -2214,8 +2519,8 @@
         </p:nvSpPr>
         <p:spPr>
           <a:xfrm>
-            <a:off x="5183188" y="987425"/>
-            <a:ext cx="6172200" cy="4873625"/>
+            <a:off x="3575050" y="273050"/>
+            <a:ext cx="5111750" cy="5853113"/>
           </a:xfrm>
         </p:spPr>
         <p:txBody>
@@ -2252,49 +2557,44 @@
           <a:p>
             <a:pPr lvl="0"/>
             <a:r>
-              <a:rPr lang="en-US"/>
+              <a:rPr lang="en-US" smtClean="0"/>
               <a:t>Click to edit Master text styles</a:t>
             </a:r>
           </a:p>
           <a:p>
             <a:pPr lvl="1"/>
             <a:r>
-              <a:rPr lang="en-US"/>
+              <a:rPr lang="en-US" smtClean="0"/>
               <a:t>Second level</a:t>
             </a:r>
           </a:p>
           <a:p>
             <a:pPr lvl="2"/>
             <a:r>
-              <a:rPr lang="en-US"/>
+              <a:rPr lang="en-US" smtClean="0"/>
               <a:t>Third level</a:t>
             </a:r>
           </a:p>
           <a:p>
             <a:pPr lvl="3"/>
             <a:r>
-              <a:rPr lang="en-US"/>
+              <a:rPr lang="en-US" smtClean="0"/>
               <a:t>Fourth level</a:t>
             </a:r>
           </a:p>
           <a:p>
             <a:pPr lvl="4"/>
             <a:r>
-              <a:rPr lang="en-US"/>
+              <a:rPr lang="en-US" smtClean="0"/>
               <a:t>Fifth level</a:t>
             </a:r>
-          </a:p>
-        </p:txBody>
-      </p:sp>
-      <p:sp>
-        <p:nvSpPr>
-          <p:cNvPr id="4" name="Text Placeholder 3">
-            <a:extLst>
-              <a:ext uri="{FF2B5EF4-FFF2-40B4-BE49-F238E27FC236}">
-                <a16:creationId xmlns:a16="http://schemas.microsoft.com/office/drawing/2014/main" id="{F3EFCAA5-9A44-87B3-777C-E91779D62FF0}"/>
-              </a:ext>
-            </a:extLst>
-          </p:cNvPr>
+            <a:endParaRPr lang="en-US"/>
+          </a:p>
+        </p:txBody>
+      </p:sp>
+      <p:sp>
+        <p:nvSpPr>
+          <p:cNvPr id="4" name="Text Placeholder 3"/>
           <p:cNvSpPr>
             <a:spLocks noGrp="1"/>
           </p:cNvSpPr>
@@ -2304,8 +2604,8 @@
         </p:nvSpPr>
         <p:spPr>
           <a:xfrm>
-            <a:off x="839788" y="2057400"/>
-            <a:ext cx="3932237" cy="3811588"/>
+            <a:off x="457200" y="1435100"/>
+            <a:ext cx="3008313" cy="4691063"/>
           </a:xfrm>
         </p:spPr>
         <p:txBody>
@@ -2313,45 +2613,45 @@
           <a:lstStyle>
             <a:lvl1pPr marL="0" indent="0">
               <a:buNone/>
-              <a:defRPr sz="1600"/>
+              <a:defRPr sz="1400"/>
             </a:lvl1pPr>
             <a:lvl2pPr marL="457200" indent="0">
               <a:buNone/>
-              <a:defRPr sz="1400"/>
+              <a:defRPr sz="1200"/>
             </a:lvl2pPr>
             <a:lvl3pPr marL="914400" indent="0">
               <a:buNone/>
-              <a:defRPr sz="1200"/>
+              <a:defRPr sz="1000"/>
             </a:lvl3pPr>
             <a:lvl4pPr marL="1371600" indent="0">
               <a:buNone/>
-              <a:defRPr sz="1000"/>
+              <a:defRPr sz="900"/>
             </a:lvl4pPr>
             <a:lvl5pPr marL="1828800" indent="0">
               <a:buNone/>
-              <a:defRPr sz="1000"/>
+              <a:defRPr sz="900"/>
             </a:lvl5pPr>
             <a:lvl6pPr marL="2286000" indent="0">
               <a:buNone/>
-              <a:defRPr sz="1000"/>
+              <a:defRPr sz="900"/>
             </a:lvl6pPr>
             <a:lvl7pPr marL="2743200" indent="0">
               <a:buNone/>
-              <a:defRPr sz="1000"/>
+              <a:defRPr sz="900"/>
             </a:lvl7pPr>
             <a:lvl8pPr marL="3200400" indent="0">
               <a:buNone/>
-              <a:defRPr sz="1000"/>
+              <a:defRPr sz="900"/>
             </a:lvl8pPr>
             <a:lvl9pPr marL="3657600" indent="0">
               <a:buNone/>
-              <a:defRPr sz="1000"/>
+              <a:defRPr sz="900"/>
             </a:lvl9pPr>
           </a:lstStyle>
           <a:p>
             <a:pPr lvl="0"/>
             <a:r>
-              <a:rPr lang="en-US"/>
+              <a:rPr lang="en-US" smtClean="0"/>
               <a:t>Click to edit Master text styles</a:t>
             </a:r>
           </a:p>
@@ -2359,13 +2659,7 @@
       </p:sp>
       <p:sp>
         <p:nvSpPr>
-          <p:cNvPr id="5" name="Date Placeholder 4">
-            <a:extLst>
-              <a:ext uri="{FF2B5EF4-FFF2-40B4-BE49-F238E27FC236}">
-                <a16:creationId xmlns:a16="http://schemas.microsoft.com/office/drawing/2014/main" id="{46CB7CDC-73B8-D07E-7134-729BD07B3236}"/>
-              </a:ext>
-            </a:extLst>
-          </p:cNvPr>
+          <p:cNvPr id="5" name="Date Placeholder 4"/>
           <p:cNvSpPr>
             <a:spLocks noGrp="1"/>
           </p:cNvSpPr>
@@ -2378,9 +2672,9 @@
           <a:bodyPr/>
           <a:lstStyle/>
           <a:p>
-            <a:fld id="{22C88FD7-B5A4-B541-9894-CD062EA3E37C}" type="datetimeFigureOut">
-              <a:rPr lang="en-US" smtClean="0"/>
-              <a:t>1/30/26</a:t>
+            <a:fld id="{5BCAD085-E8A6-8845-BD4E-CB4CCA059FC4}" type="datetimeFigureOut">
+              <a:rPr lang="en-US" smtClean="0"/>
+              <a:t>1/27/13</a:t>
             </a:fld>
             <a:endParaRPr lang="en-US"/>
           </a:p>
@@ -2388,13 +2682,7 @@
       </p:sp>
       <p:sp>
         <p:nvSpPr>
-          <p:cNvPr id="6" name="Footer Placeholder 5">
-            <a:extLst>
-              <a:ext uri="{FF2B5EF4-FFF2-40B4-BE49-F238E27FC236}">
-                <a16:creationId xmlns:a16="http://schemas.microsoft.com/office/drawing/2014/main" id="{E3127E8C-8992-124E-BA13-45852A65462B}"/>
-              </a:ext>
-            </a:extLst>
-          </p:cNvPr>
+          <p:cNvPr id="6" name="Footer Placeholder 5"/>
           <p:cNvSpPr>
             <a:spLocks noGrp="1"/>
           </p:cNvSpPr>
@@ -2413,13 +2701,7 @@
       </p:sp>
       <p:sp>
         <p:nvSpPr>
-          <p:cNvPr id="7" name="Slide Number Placeholder 6">
-            <a:extLst>
-              <a:ext uri="{FF2B5EF4-FFF2-40B4-BE49-F238E27FC236}">
-                <a16:creationId xmlns:a16="http://schemas.microsoft.com/office/drawing/2014/main" id="{526B69D6-BEAF-0A83-91DC-0FE0C0C01009}"/>
-              </a:ext>
-            </a:extLst>
-          </p:cNvPr>
+          <p:cNvPr id="7" name="Slide Number Placeholder 6"/>
           <p:cNvSpPr>
             <a:spLocks noGrp="1"/>
           </p:cNvSpPr>
@@ -2432,7 +2714,7 @@
           <a:bodyPr/>
           <a:lstStyle/>
           <a:p>
-            <a:fld id="{F32E41F8-49F7-CD4A-BC3D-8F020394F209}" type="slidenum">
+            <a:fld id="{C1FF6DA9-008F-8B48-92A6-B652298478BF}" type="slidenum">
               <a:rPr lang="en-US" smtClean="0"/>
               <a:t>‹#›</a:t>
             </a:fld>
@@ -2443,7 +2725,7 @@
     </p:spTree>
     <p:extLst>
       <p:ext uri="{BB962C8B-B14F-4D97-AF65-F5344CB8AC3E}">
-        <p14:creationId xmlns:p14="http://schemas.microsoft.com/office/powerpoint/2010/main" val="3807159829"/>
+        <p14:creationId xmlns:p14="http://schemas.microsoft.com/office/powerpoint/2010/main" val="1840726560"/>
       </p:ext>
     </p:extLst>
   </p:cSld>
@@ -2472,13 +2754,7 @@
       </p:grpSpPr>
       <p:sp>
         <p:nvSpPr>
-          <p:cNvPr id="2" name="Title 1">
-            <a:extLst>
-              <a:ext uri="{FF2B5EF4-FFF2-40B4-BE49-F238E27FC236}">
-                <a16:creationId xmlns:a16="http://schemas.microsoft.com/office/drawing/2014/main" id="{2D65681D-5C9B-CA74-D29C-E0102D59986C}"/>
-              </a:ext>
-            </a:extLst>
-          </p:cNvPr>
+          <p:cNvPr id="2" name="Title 1"/>
           <p:cNvSpPr>
             <a:spLocks noGrp="1"/>
           </p:cNvSpPr>
@@ -2488,34 +2764,29 @@
         </p:nvSpPr>
         <p:spPr>
           <a:xfrm>
-            <a:off x="839788" y="457200"/>
-            <a:ext cx="3932237" cy="1600200"/>
+            <a:off x="1792288" y="4800600"/>
+            <a:ext cx="5486400" cy="566738"/>
           </a:xfrm>
         </p:spPr>
         <p:txBody>
           <a:bodyPr anchor="b"/>
           <a:lstStyle>
-            <a:lvl1pPr>
-              <a:defRPr sz="3200"/>
+            <a:lvl1pPr algn="l">
+              <a:defRPr sz="2000" b="1"/>
             </a:lvl1pPr>
           </a:lstStyle>
           <a:p>
             <a:r>
-              <a:rPr lang="en-US"/>
+              <a:rPr lang="en-US" smtClean="0"/>
               <a:t>Click to edit Master title style</a:t>
             </a:r>
-          </a:p>
-        </p:txBody>
-      </p:sp>
-      <p:sp>
-        <p:nvSpPr>
-          <p:cNvPr id="3" name="Picture Placeholder 2">
-            <a:extLst>
-              <a:ext uri="{FF2B5EF4-FFF2-40B4-BE49-F238E27FC236}">
-                <a16:creationId xmlns:a16="http://schemas.microsoft.com/office/drawing/2014/main" id="{84DA051D-118A-4635-3D07-65A0B5265044}"/>
-              </a:ext>
-            </a:extLst>
-          </p:cNvPr>
+            <a:endParaRPr lang="en-US"/>
+          </a:p>
+        </p:txBody>
+      </p:sp>
+      <p:sp>
+        <p:nvSpPr>
+          <p:cNvPr id="3" name="Picture Placeholder 2"/>
           <p:cNvSpPr>
             <a:spLocks noGrp="1"/>
           </p:cNvSpPr>
@@ -2525,8 +2796,8 @@
         </p:nvSpPr>
         <p:spPr>
           <a:xfrm>
-            <a:off x="5183188" y="987425"/>
-            <a:ext cx="6172200" cy="4873625"/>
+            <a:off x="1792288" y="612775"/>
+            <a:ext cx="5486400" cy="4114800"/>
           </a:xfrm>
         </p:spPr>
         <p:txBody>
@@ -2576,13 +2847,7 @@
       </p:sp>
       <p:sp>
         <p:nvSpPr>
-          <p:cNvPr id="4" name="Text Placeholder 3">
-            <a:extLst>
-              <a:ext uri="{FF2B5EF4-FFF2-40B4-BE49-F238E27FC236}">
-                <a16:creationId xmlns:a16="http://schemas.microsoft.com/office/drawing/2014/main" id="{EDDBEE97-66B3-A647-8C30-1D170FF28BA5}"/>
-              </a:ext>
-            </a:extLst>
-          </p:cNvPr>
+          <p:cNvPr id="4" name="Text Placeholder 3"/>
           <p:cNvSpPr>
             <a:spLocks noGrp="1"/>
           </p:cNvSpPr>
@@ -2592,8 +2857,8 @@
         </p:nvSpPr>
         <p:spPr>
           <a:xfrm>
-            <a:off x="839788" y="2057400"/>
-            <a:ext cx="3932237" cy="3811588"/>
+            <a:off x="1792288" y="5367338"/>
+            <a:ext cx="5486400" cy="804862"/>
           </a:xfrm>
         </p:spPr>
         <p:txBody>
@@ -2601,45 +2866,45 @@
           <a:lstStyle>
             <a:lvl1pPr marL="0" indent="0">
               <a:buNone/>
-              <a:defRPr sz="1600"/>
+              <a:defRPr sz="1400"/>
             </a:lvl1pPr>
             <a:lvl2pPr marL="457200" indent="0">
               <a:buNone/>
-              <a:defRPr sz="1400"/>
+              <a:defRPr sz="1200"/>
             </a:lvl2pPr>
             <a:lvl3pPr marL="914400" indent="0">
               <a:buNone/>
-              <a:defRPr sz="1200"/>
+              <a:defRPr sz="1000"/>
             </a:lvl3pPr>
             <a:lvl4pPr marL="1371600" indent="0">
               <a:buNone/>
-              <a:defRPr sz="1000"/>
+              <a:defRPr sz="900"/>
             </a:lvl4pPr>
             <a:lvl5pPr marL="1828800" indent="0">
               <a:buNone/>
-              <a:defRPr sz="1000"/>
+              <a:defRPr sz="900"/>
             </a:lvl5pPr>
             <a:lvl6pPr marL="2286000" indent="0">
               <a:buNone/>
-              <a:defRPr sz="1000"/>
+              <a:defRPr sz="900"/>
             </a:lvl6pPr>
             <a:lvl7pPr marL="2743200" indent="0">
               <a:buNone/>
-              <a:defRPr sz="1000"/>
+              <a:defRPr sz="900"/>
             </a:lvl7pPr>
             <a:lvl8pPr marL="3200400" indent="0">
               <a:buNone/>
-              <a:defRPr sz="1000"/>
+              <a:defRPr sz="900"/>
             </a:lvl8pPr>
             <a:lvl9pPr marL="3657600" indent="0">
               <a:buNone/>
-              <a:defRPr sz="1000"/>
+              <a:defRPr sz="900"/>
             </a:lvl9pPr>
           </a:lstStyle>
           <a:p>
             <a:pPr lvl="0"/>
             <a:r>
-              <a:rPr lang="en-US"/>
+              <a:rPr lang="en-US" smtClean="0"/>
               <a:t>Click to edit Master text styles</a:t>
             </a:r>
           </a:p>
@@ -2647,13 +2912,7 @@
       </p:sp>
       <p:sp>
         <p:nvSpPr>
-          <p:cNvPr id="5" name="Date Placeholder 4">
-            <a:extLst>
-              <a:ext uri="{FF2B5EF4-FFF2-40B4-BE49-F238E27FC236}">
-                <a16:creationId xmlns:a16="http://schemas.microsoft.com/office/drawing/2014/main" id="{DE0D4A1E-4BA3-BA5B-5C38-0EBCB026770F}"/>
-              </a:ext>
-            </a:extLst>
-          </p:cNvPr>
+          <p:cNvPr id="5" name="Date Placeholder 4"/>
           <p:cNvSpPr>
             <a:spLocks noGrp="1"/>
           </p:cNvSpPr>
@@ -2666,9 +2925,9 @@
           <a:bodyPr/>
           <a:lstStyle/>
           <a:p>
-            <a:fld id="{22C88FD7-B5A4-B541-9894-CD062EA3E37C}" type="datetimeFigureOut">
-              <a:rPr lang="en-US" smtClean="0"/>
-              <a:t>1/30/26</a:t>
+            <a:fld id="{5BCAD085-E8A6-8845-BD4E-CB4CCA059FC4}" type="datetimeFigureOut">
+              <a:rPr lang="en-US" smtClean="0"/>
+              <a:t>1/27/13</a:t>
             </a:fld>
             <a:endParaRPr lang="en-US"/>
           </a:p>
@@ -2676,13 +2935,7 @@
       </p:sp>
       <p:sp>
         <p:nvSpPr>
-          <p:cNvPr id="6" name="Footer Placeholder 5">
-            <a:extLst>
-              <a:ext uri="{FF2B5EF4-FFF2-40B4-BE49-F238E27FC236}">
-                <a16:creationId xmlns:a16="http://schemas.microsoft.com/office/drawing/2014/main" id="{B7F46298-93E0-88EA-9C27-71A6F3D6890D}"/>
-              </a:ext>
-            </a:extLst>
-          </p:cNvPr>
+          <p:cNvPr id="6" name="Footer Placeholder 5"/>
           <p:cNvSpPr>
             <a:spLocks noGrp="1"/>
           </p:cNvSpPr>
@@ -2701,13 +2954,7 @@
       </p:sp>
       <p:sp>
         <p:nvSpPr>
-          <p:cNvPr id="7" name="Slide Number Placeholder 6">
-            <a:extLst>
-              <a:ext uri="{FF2B5EF4-FFF2-40B4-BE49-F238E27FC236}">
-                <a16:creationId xmlns:a16="http://schemas.microsoft.com/office/drawing/2014/main" id="{BA261EDD-B738-4606-50C3-D7B014A624D2}"/>
-              </a:ext>
-            </a:extLst>
-          </p:cNvPr>
+          <p:cNvPr id="7" name="Slide Number Placeholder 6"/>
           <p:cNvSpPr>
             <a:spLocks noGrp="1"/>
           </p:cNvSpPr>
@@ -2720,7 +2967,7 @@
           <a:bodyPr/>
           <a:lstStyle/>
           <a:p>
-            <a:fld id="{F32E41F8-49F7-CD4A-BC3D-8F020394F209}" type="slidenum">
+            <a:fld id="{C1FF6DA9-008F-8B48-92A6-B652298478BF}" type="slidenum">
               <a:rPr lang="en-US" smtClean="0"/>
               <a:t>‹#›</a:t>
             </a:fld>
@@ -2731,7 +2978,7 @@
     </p:spTree>
     <p:extLst>
       <p:ext uri="{BB962C8B-B14F-4D97-AF65-F5344CB8AC3E}">
-        <p14:creationId xmlns:p14="http://schemas.microsoft.com/office/powerpoint/2010/main" val="3768613802"/>
+        <p14:creationId xmlns:p14="http://schemas.microsoft.com/office/powerpoint/2010/main" val="3889236939"/>
       </p:ext>
     </p:extLst>
   </p:cSld>
@@ -2765,13 +3012,7 @@
       </p:grpSpPr>
       <p:sp>
         <p:nvSpPr>
-          <p:cNvPr id="2" name="Title Placeholder 1">
-            <a:extLst>
-              <a:ext uri="{FF2B5EF4-FFF2-40B4-BE49-F238E27FC236}">
-                <a16:creationId xmlns:a16="http://schemas.microsoft.com/office/drawing/2014/main" id="{569C8DD0-A892-E922-F198-4D5EA79A7F7D}"/>
-              </a:ext>
-            </a:extLst>
-          </p:cNvPr>
+          <p:cNvPr id="2" name="Title Placeholder 1"/>
           <p:cNvSpPr>
             <a:spLocks noGrp="1"/>
           </p:cNvSpPr>
@@ -2781,8 +3022,8 @@
         </p:nvSpPr>
         <p:spPr>
           <a:xfrm>
-            <a:off x="838200" y="365125"/>
-            <a:ext cx="10515600" cy="1325563"/>
+            <a:off x="457200" y="274638"/>
+            <a:ext cx="8229600" cy="1143000"/>
           </a:xfrm>
           <a:prstGeom prst="rect">
             <a:avLst/>
@@ -2795,21 +3036,16 @@
           <a:lstStyle/>
           <a:p>
             <a:r>
-              <a:rPr lang="en-US"/>
+              <a:rPr lang="en-US" smtClean="0"/>
               <a:t>Click to edit Master title style</a:t>
             </a:r>
-          </a:p>
-        </p:txBody>
-      </p:sp>
-      <p:sp>
-        <p:nvSpPr>
-          <p:cNvPr id="3" name="Text Placeholder 2">
-            <a:extLst>
-              <a:ext uri="{FF2B5EF4-FFF2-40B4-BE49-F238E27FC236}">
-                <a16:creationId xmlns:a16="http://schemas.microsoft.com/office/drawing/2014/main" id="{F24DE710-1C8E-1C41-FBF7-50EB906DC483}"/>
-              </a:ext>
-            </a:extLst>
-          </p:cNvPr>
+            <a:endParaRPr lang="en-US"/>
+          </a:p>
+        </p:txBody>
+      </p:sp>
+      <p:sp>
+        <p:nvSpPr>
+          <p:cNvPr id="3" name="Text Placeholder 2"/>
           <p:cNvSpPr>
             <a:spLocks noGrp="1"/>
           </p:cNvSpPr>
@@ -2819,8 +3055,8 @@
         </p:nvSpPr>
         <p:spPr>
           <a:xfrm>
-            <a:off x="838200" y="1825625"/>
-            <a:ext cx="10515600" cy="4351338"/>
+            <a:off x="457200" y="1600200"/>
+            <a:ext cx="8229600" cy="4525963"/>
           </a:xfrm>
           <a:prstGeom prst="rect">
             <a:avLst/>
@@ -2834,49 +3070,44 @@
           <a:p>
             <a:pPr lvl="0"/>
             <a:r>
-              <a:rPr lang="en-US"/>
+              <a:rPr lang="en-US" smtClean="0"/>
               <a:t>Click to edit Master text styles</a:t>
             </a:r>
           </a:p>
           <a:p>
             <a:pPr lvl="1"/>
             <a:r>
-              <a:rPr lang="en-US"/>
+              <a:rPr lang="en-US" smtClean="0"/>
               <a:t>Second level</a:t>
             </a:r>
           </a:p>
           <a:p>
             <a:pPr lvl="2"/>
             <a:r>
-              <a:rPr lang="en-US"/>
+              <a:rPr lang="en-US" smtClean="0"/>
               <a:t>Third level</a:t>
             </a:r>
           </a:p>
           <a:p>
             <a:pPr lvl="3"/>
             <a:r>
-              <a:rPr lang="en-US"/>
+              <a:rPr lang="en-US" smtClean="0"/>
               <a:t>Fourth level</a:t>
             </a:r>
           </a:p>
           <a:p>
             <a:pPr lvl="4"/>
             <a:r>
-              <a:rPr lang="en-US"/>
+              <a:rPr lang="en-US" smtClean="0"/>
               <a:t>Fifth level</a:t>
             </a:r>
-          </a:p>
-        </p:txBody>
-      </p:sp>
-      <p:sp>
-        <p:nvSpPr>
-          <p:cNvPr id="4" name="Date Placeholder 3">
-            <a:extLst>
-              <a:ext uri="{FF2B5EF4-FFF2-40B4-BE49-F238E27FC236}">
-                <a16:creationId xmlns:a16="http://schemas.microsoft.com/office/drawing/2014/main" id="{E15E5426-5A5E-FD0F-DEC7-A401923E18E1}"/>
-              </a:ext>
-            </a:extLst>
-          </p:cNvPr>
+            <a:endParaRPr lang="en-US"/>
+          </a:p>
+        </p:txBody>
+      </p:sp>
+      <p:sp>
+        <p:nvSpPr>
+          <p:cNvPr id="4" name="Date Placeholder 3"/>
           <p:cNvSpPr>
             <a:spLocks noGrp="1"/>
           </p:cNvSpPr>
@@ -2886,8 +3117,8 @@
         </p:nvSpPr>
         <p:spPr>
           <a:xfrm>
-            <a:off x="838200" y="6356350"/>
-            <a:ext cx="2743200" cy="365125"/>
+            <a:off x="457200" y="6356350"/>
+            <a:ext cx="2133600" cy="365125"/>
           </a:xfrm>
           <a:prstGeom prst="rect">
             <a:avLst/>
@@ -2900,16 +3131,16 @@
               <a:defRPr sz="1200">
                 <a:solidFill>
                   <a:schemeClr val="tx1">
-                    <a:tint val="82000"/>
+                    <a:tint val="75000"/>
                   </a:schemeClr>
                 </a:solidFill>
               </a:defRPr>
             </a:lvl1pPr>
           </a:lstStyle>
           <a:p>
-            <a:fld id="{22C88FD7-B5A4-B541-9894-CD062EA3E37C}" type="datetimeFigureOut">
-              <a:rPr lang="en-US" smtClean="0"/>
-              <a:t>1/30/26</a:t>
+            <a:fld id="{5BCAD085-E8A6-8845-BD4E-CB4CCA059FC4}" type="datetimeFigureOut">
+              <a:rPr lang="en-US" smtClean="0"/>
+              <a:t>1/27/13</a:t>
             </a:fld>
             <a:endParaRPr lang="en-US"/>
           </a:p>
@@ -2917,13 +3148,7 @@
       </p:sp>
       <p:sp>
         <p:nvSpPr>
-          <p:cNvPr id="5" name="Footer Placeholder 4">
-            <a:extLst>
-              <a:ext uri="{FF2B5EF4-FFF2-40B4-BE49-F238E27FC236}">
-                <a16:creationId xmlns:a16="http://schemas.microsoft.com/office/drawing/2014/main" id="{FCE20220-FCF3-046A-4BEB-1EA93319163A}"/>
-              </a:ext>
-            </a:extLst>
-          </p:cNvPr>
+          <p:cNvPr id="5" name="Footer Placeholder 4"/>
           <p:cNvSpPr>
             <a:spLocks noGrp="1"/>
           </p:cNvSpPr>
@@ -2933,8 +3158,8 @@
         </p:nvSpPr>
         <p:spPr>
           <a:xfrm>
-            <a:off x="4038600" y="6356350"/>
-            <a:ext cx="4114800" cy="365125"/>
+            <a:off x="3124200" y="6356350"/>
+            <a:ext cx="2895600" cy="365125"/>
           </a:xfrm>
           <a:prstGeom prst="rect">
             <a:avLst/>
@@ -2947,7 +3172,7 @@
               <a:defRPr sz="1200">
                 <a:solidFill>
                   <a:schemeClr val="tx1">
-                    <a:tint val="82000"/>
+                    <a:tint val="75000"/>
                   </a:schemeClr>
                 </a:solidFill>
               </a:defRPr>
@@ -2960,13 +3185,7 @@
       </p:sp>
       <p:sp>
         <p:nvSpPr>
-          <p:cNvPr id="6" name="Slide Number Placeholder 5">
-            <a:extLst>
-              <a:ext uri="{FF2B5EF4-FFF2-40B4-BE49-F238E27FC236}">
-                <a16:creationId xmlns:a16="http://schemas.microsoft.com/office/drawing/2014/main" id="{62DAC3C0-6E0E-1C8F-E49F-7BD5F05D579D}"/>
-              </a:ext>
-            </a:extLst>
-          </p:cNvPr>
+          <p:cNvPr id="6" name="Slide Number Placeholder 5"/>
           <p:cNvSpPr>
             <a:spLocks noGrp="1"/>
           </p:cNvSpPr>
@@ -2976,8 +3195,8 @@
         </p:nvSpPr>
         <p:spPr>
           <a:xfrm>
-            <a:off x="8610600" y="6356350"/>
-            <a:ext cx="2743200" cy="365125"/>
+            <a:off x="6553200" y="6356350"/>
+            <a:ext cx="2133600" cy="365125"/>
           </a:xfrm>
           <a:prstGeom prst="rect">
             <a:avLst/>
@@ -2990,14 +3209,14 @@
               <a:defRPr sz="1200">
                 <a:solidFill>
                   <a:schemeClr val="tx1">
-                    <a:tint val="82000"/>
+                    <a:tint val="75000"/>
                   </a:schemeClr>
                 </a:solidFill>
               </a:defRPr>
             </a:lvl1pPr>
           </a:lstStyle>
           <a:p>
-            <a:fld id="{F32E41F8-49F7-CD4A-BC3D-8F020394F209}" type="slidenum">
+            <a:fld id="{C1FF6DA9-008F-8B48-92A6-B652298478BF}" type="slidenum">
               <a:rPr lang="en-US" smtClean="0"/>
               <a:t>‹#›</a:t>
             </a:fld>
@@ -3008,7 +3227,7 @@
     </p:spTree>
     <p:extLst>
       <p:ext uri="{BB962C8B-B14F-4D97-AF65-F5344CB8AC3E}">
-        <p14:creationId xmlns:p14="http://schemas.microsoft.com/office/powerpoint/2010/main" val="1616474723"/>
+        <p14:creationId xmlns:p14="http://schemas.microsoft.com/office/powerpoint/2010/main" val="2209977519"/>
       </p:ext>
     </p:extLst>
   </p:cSld>
@@ -3028,10 +3247,7 @@
   </p:sldLayoutIdLst>
   <p:txStyles>
     <p:titleStyle>
-      <a:lvl1pPr algn="l" defTabSz="914400" rtl="0" eaLnBrk="1" latinLnBrk="0" hangingPunct="1">
-        <a:lnSpc>
-          <a:spcPct val="90000"/>
-        </a:lnSpc>
+      <a:lvl1pPr algn="ctr" defTabSz="457200" rtl="0" eaLnBrk="1" latinLnBrk="0" hangingPunct="1">
         <a:spcBef>
           <a:spcPct val="0"/>
         </a:spcBef>
@@ -3047,15 +3263,27 @@
       </a:lvl1pPr>
     </p:titleStyle>
     <p:bodyStyle>
-      <a:lvl1pPr marL="228600" indent="-228600" algn="l" defTabSz="914400" rtl="0" eaLnBrk="1" latinLnBrk="0" hangingPunct="1">
-        <a:lnSpc>
-          <a:spcPct val="90000"/>
-        </a:lnSpc>
+      <a:lvl1pPr marL="342900" indent="-342900" algn="l" defTabSz="457200" rtl="0" eaLnBrk="1" latinLnBrk="0" hangingPunct="1">
         <a:spcBef>
-          <a:spcPts val="1000"/>
+          <a:spcPct val="20000"/>
         </a:spcBef>
-        <a:buFont typeface="Arial" panose="020B0604020202020204" pitchFamily="34" charset="0"/>
+        <a:buFont typeface="Arial"/>
         <a:buChar char="•"/>
+        <a:defRPr sz="3200" kern="1200">
+          <a:solidFill>
+            <a:schemeClr val="tx1"/>
+          </a:solidFill>
+          <a:latin typeface="+mn-lt"/>
+          <a:ea typeface="+mn-ea"/>
+          <a:cs typeface="+mn-cs"/>
+        </a:defRPr>
+      </a:lvl1pPr>
+      <a:lvl2pPr marL="742950" indent="-285750" algn="l" defTabSz="457200" rtl="0" eaLnBrk="1" latinLnBrk="0" hangingPunct="1">
+        <a:spcBef>
+          <a:spcPct val="20000"/>
+        </a:spcBef>
+        <a:buFont typeface="Arial"/>
+        <a:buChar char="–"/>
         <a:defRPr sz="2800" kern="1200">
           <a:solidFill>
             <a:schemeClr val="tx1"/>
@@ -3064,15 +3292,12 @@
           <a:ea typeface="+mn-ea"/>
           <a:cs typeface="+mn-cs"/>
         </a:defRPr>
-      </a:lvl1pPr>
-      <a:lvl2pPr marL="685800" indent="-228600" algn="l" defTabSz="914400" rtl="0" eaLnBrk="1" latinLnBrk="0" hangingPunct="1">
-        <a:lnSpc>
-          <a:spcPct val="90000"/>
-        </a:lnSpc>
+      </a:lvl2pPr>
+      <a:lvl3pPr marL="1143000" indent="-228600" algn="l" defTabSz="457200" rtl="0" eaLnBrk="1" latinLnBrk="0" hangingPunct="1">
         <a:spcBef>
-          <a:spcPts val="500"/>
+          <a:spcPct val="20000"/>
         </a:spcBef>
-        <a:buFont typeface="Arial" panose="020B0604020202020204" pitchFamily="34" charset="0"/>
+        <a:buFont typeface="Arial"/>
         <a:buChar char="•"/>
         <a:defRPr sz="2400" kern="1200">
           <a:solidFill>
@@ -3082,15 +3307,42 @@
           <a:ea typeface="+mn-ea"/>
           <a:cs typeface="+mn-cs"/>
         </a:defRPr>
-      </a:lvl2pPr>
-      <a:lvl3pPr marL="1143000" indent="-228600" algn="l" defTabSz="914400" rtl="0" eaLnBrk="1" latinLnBrk="0" hangingPunct="1">
-        <a:lnSpc>
-          <a:spcPct val="90000"/>
-        </a:lnSpc>
+      </a:lvl3pPr>
+      <a:lvl4pPr marL="1600200" indent="-228600" algn="l" defTabSz="457200" rtl="0" eaLnBrk="1" latinLnBrk="0" hangingPunct="1">
         <a:spcBef>
-          <a:spcPts val="500"/>
+          <a:spcPct val="20000"/>
         </a:spcBef>
-        <a:buFont typeface="Arial" panose="020B0604020202020204" pitchFamily="34" charset="0"/>
+        <a:buFont typeface="Arial"/>
+        <a:buChar char="–"/>
+        <a:defRPr sz="2000" kern="1200">
+          <a:solidFill>
+            <a:schemeClr val="tx1"/>
+          </a:solidFill>
+          <a:latin typeface="+mn-lt"/>
+          <a:ea typeface="+mn-ea"/>
+          <a:cs typeface="+mn-cs"/>
+        </a:defRPr>
+      </a:lvl4pPr>
+      <a:lvl5pPr marL="2057400" indent="-228600" algn="l" defTabSz="457200" rtl="0" eaLnBrk="1" latinLnBrk="0" hangingPunct="1">
+        <a:spcBef>
+          <a:spcPct val="20000"/>
+        </a:spcBef>
+        <a:buFont typeface="Arial"/>
+        <a:buChar char="»"/>
+        <a:defRPr sz="2000" kern="1200">
+          <a:solidFill>
+            <a:schemeClr val="tx1"/>
+          </a:solidFill>
+          <a:latin typeface="+mn-lt"/>
+          <a:ea typeface="+mn-ea"/>
+          <a:cs typeface="+mn-cs"/>
+        </a:defRPr>
+      </a:lvl5pPr>
+      <a:lvl6pPr marL="2514600" indent="-228600" algn="l" defTabSz="457200" rtl="0" eaLnBrk="1" latinLnBrk="0" hangingPunct="1">
+        <a:spcBef>
+          <a:spcPct val="20000"/>
+        </a:spcBef>
+        <a:buFont typeface="Arial"/>
         <a:buChar char="•"/>
         <a:defRPr sz="2000" kern="1200">
           <a:solidFill>
@@ -3100,71 +3352,14 @@
           <a:ea typeface="+mn-ea"/>
           <a:cs typeface="+mn-cs"/>
         </a:defRPr>
-      </a:lvl3pPr>
-      <a:lvl4pPr marL="1600200" indent="-228600" algn="l" defTabSz="914400" rtl="0" eaLnBrk="1" latinLnBrk="0" hangingPunct="1">
-        <a:lnSpc>
-          <a:spcPct val="90000"/>
-        </a:lnSpc>
+      </a:lvl6pPr>
+      <a:lvl7pPr marL="2971800" indent="-228600" algn="l" defTabSz="457200" rtl="0" eaLnBrk="1" latinLnBrk="0" hangingPunct="1">
         <a:spcBef>
-          <a:spcPts val="500"/>
+          <a:spcPct val="20000"/>
         </a:spcBef>
-        <a:buFont typeface="Arial" panose="020B0604020202020204" pitchFamily="34" charset="0"/>
+        <a:buFont typeface="Arial"/>
         <a:buChar char="•"/>
-        <a:defRPr sz="1800" kern="1200">
-          <a:solidFill>
-            <a:schemeClr val="tx1"/>
-          </a:solidFill>
-          <a:latin typeface="+mn-lt"/>
-          <a:ea typeface="+mn-ea"/>
-          <a:cs typeface="+mn-cs"/>
-        </a:defRPr>
-      </a:lvl4pPr>
-      <a:lvl5pPr marL="2057400" indent="-228600" algn="l" defTabSz="914400" rtl="0" eaLnBrk="1" latinLnBrk="0" hangingPunct="1">
-        <a:lnSpc>
-          <a:spcPct val="90000"/>
-        </a:lnSpc>
-        <a:spcBef>
-          <a:spcPts val="500"/>
-        </a:spcBef>
-        <a:buFont typeface="Arial" panose="020B0604020202020204" pitchFamily="34" charset="0"/>
-        <a:buChar char="•"/>
-        <a:defRPr sz="1800" kern="1200">
-          <a:solidFill>
-            <a:schemeClr val="tx1"/>
-          </a:solidFill>
-          <a:latin typeface="+mn-lt"/>
-          <a:ea typeface="+mn-ea"/>
-          <a:cs typeface="+mn-cs"/>
-        </a:defRPr>
-      </a:lvl5pPr>
-      <a:lvl6pPr marL="2514600" indent="-228600" algn="l" defTabSz="914400" rtl="0" eaLnBrk="1" latinLnBrk="0" hangingPunct="1">
-        <a:lnSpc>
-          <a:spcPct val="90000"/>
-        </a:lnSpc>
-        <a:spcBef>
-          <a:spcPts val="500"/>
-        </a:spcBef>
-        <a:buFont typeface="Arial" panose="020B0604020202020204" pitchFamily="34" charset="0"/>
-        <a:buChar char="•"/>
-        <a:defRPr sz="1800" kern="1200">
-          <a:solidFill>
-            <a:schemeClr val="tx1"/>
-          </a:solidFill>
-          <a:latin typeface="+mn-lt"/>
-          <a:ea typeface="+mn-ea"/>
-          <a:cs typeface="+mn-cs"/>
-        </a:defRPr>
-      </a:lvl6pPr>
-      <a:lvl7pPr marL="2971800" indent="-228600" algn="l" defTabSz="914400" rtl="0" eaLnBrk="1" latinLnBrk="0" hangingPunct="1">
-        <a:lnSpc>
-          <a:spcPct val="90000"/>
-        </a:lnSpc>
-        <a:spcBef>
-          <a:spcPts val="500"/>
-        </a:spcBef>
-        <a:buFont typeface="Arial" panose="020B0604020202020204" pitchFamily="34" charset="0"/>
-        <a:buChar char="•"/>
-        <a:defRPr sz="1800" kern="1200">
+        <a:defRPr sz="2000" kern="1200">
           <a:solidFill>
             <a:schemeClr val="tx1"/>
           </a:solidFill>
@@ -3173,16 +3368,13 @@
           <a:cs typeface="+mn-cs"/>
         </a:defRPr>
       </a:lvl7pPr>
-      <a:lvl8pPr marL="3429000" indent="-228600" algn="l" defTabSz="914400" rtl="0" eaLnBrk="1" latinLnBrk="0" hangingPunct="1">
-        <a:lnSpc>
-          <a:spcPct val="90000"/>
-        </a:lnSpc>
+      <a:lvl8pPr marL="3429000" indent="-228600" algn="l" defTabSz="457200" rtl="0" eaLnBrk="1" latinLnBrk="0" hangingPunct="1">
         <a:spcBef>
-          <a:spcPts val="500"/>
+          <a:spcPct val="20000"/>
         </a:spcBef>
-        <a:buFont typeface="Arial" panose="020B0604020202020204" pitchFamily="34" charset="0"/>
+        <a:buFont typeface="Arial"/>
         <a:buChar char="•"/>
-        <a:defRPr sz="1800" kern="1200">
+        <a:defRPr sz="2000" kern="1200">
           <a:solidFill>
             <a:schemeClr val="tx1"/>
           </a:solidFill>
@@ -3191,16 +3383,13 @@
           <a:cs typeface="+mn-cs"/>
         </a:defRPr>
       </a:lvl8pPr>
-      <a:lvl9pPr marL="3886200" indent="-228600" algn="l" defTabSz="914400" rtl="0" eaLnBrk="1" latinLnBrk="0" hangingPunct="1">
-        <a:lnSpc>
-          <a:spcPct val="90000"/>
-        </a:lnSpc>
+      <a:lvl9pPr marL="3886200" indent="-228600" algn="l" defTabSz="457200" rtl="0" eaLnBrk="1" latinLnBrk="0" hangingPunct="1">
         <a:spcBef>
-          <a:spcPts val="500"/>
+          <a:spcPct val="20000"/>
         </a:spcBef>
-        <a:buFont typeface="Arial" panose="020B0604020202020204" pitchFamily="34" charset="0"/>
+        <a:buFont typeface="Arial"/>
         <a:buChar char="•"/>
-        <a:defRPr sz="1800" kern="1200">
+        <a:defRPr sz="2000" kern="1200">
           <a:solidFill>
             <a:schemeClr val="tx1"/>
           </a:solidFill>
@@ -3214,7 +3403,7 @@
       <a:defPPr>
         <a:defRPr lang="en-US"/>
       </a:defPPr>
-      <a:lvl1pPr marL="0" algn="l" defTabSz="914400" rtl="0" eaLnBrk="1" latinLnBrk="0" hangingPunct="1">
+      <a:lvl1pPr marL="0" algn="l" defTabSz="457200" rtl="0" eaLnBrk="1" latinLnBrk="0" hangingPunct="1">
         <a:defRPr sz="1800" kern="1200">
           <a:solidFill>
             <a:schemeClr val="tx1"/>
@@ -3224,7 +3413,7 @@
           <a:cs typeface="+mn-cs"/>
         </a:defRPr>
       </a:lvl1pPr>
-      <a:lvl2pPr marL="457200" algn="l" defTabSz="914400" rtl="0" eaLnBrk="1" latinLnBrk="0" hangingPunct="1">
+      <a:lvl2pPr marL="457200" algn="l" defTabSz="457200" rtl="0" eaLnBrk="1" latinLnBrk="0" hangingPunct="1">
         <a:defRPr sz="1800" kern="1200">
           <a:solidFill>
             <a:schemeClr val="tx1"/>
@@ -3234,7 +3423,7 @@
           <a:cs typeface="+mn-cs"/>
         </a:defRPr>
       </a:lvl2pPr>
-      <a:lvl3pPr marL="914400" algn="l" defTabSz="914400" rtl="0" eaLnBrk="1" latinLnBrk="0" hangingPunct="1">
+      <a:lvl3pPr marL="914400" algn="l" defTabSz="457200" rtl="0" eaLnBrk="1" latinLnBrk="0" hangingPunct="1">
         <a:defRPr sz="1800" kern="1200">
           <a:solidFill>
             <a:schemeClr val="tx1"/>
@@ -3244,7 +3433,7 @@
           <a:cs typeface="+mn-cs"/>
         </a:defRPr>
       </a:lvl3pPr>
-      <a:lvl4pPr marL="1371600" algn="l" defTabSz="914400" rtl="0" eaLnBrk="1" latinLnBrk="0" hangingPunct="1">
+      <a:lvl4pPr marL="1371600" algn="l" defTabSz="457200" rtl="0" eaLnBrk="1" latinLnBrk="0" hangingPunct="1">
         <a:defRPr sz="1800" kern="1200">
           <a:solidFill>
             <a:schemeClr val="tx1"/>
@@ -3254,7 +3443,7 @@
           <a:cs typeface="+mn-cs"/>
         </a:defRPr>
       </a:lvl4pPr>
-      <a:lvl5pPr marL="1828800" algn="l" defTabSz="914400" rtl="0" eaLnBrk="1" latinLnBrk="0" hangingPunct="1">
+      <a:lvl5pPr marL="1828800" algn="l" defTabSz="457200" rtl="0" eaLnBrk="1" latinLnBrk="0" hangingPunct="1">
         <a:defRPr sz="1800" kern="1200">
           <a:solidFill>
             <a:schemeClr val="tx1"/>
@@ -3264,7 +3453,7 @@
           <a:cs typeface="+mn-cs"/>
         </a:defRPr>
       </a:lvl5pPr>
-      <a:lvl6pPr marL="2286000" algn="l" defTabSz="914400" rtl="0" eaLnBrk="1" latinLnBrk="0" hangingPunct="1">
+      <a:lvl6pPr marL="2286000" algn="l" defTabSz="457200" rtl="0" eaLnBrk="1" latinLnBrk="0" hangingPunct="1">
         <a:defRPr sz="1800" kern="1200">
           <a:solidFill>
             <a:schemeClr val="tx1"/>
@@ -3274,7 +3463,7 @@
           <a:cs typeface="+mn-cs"/>
         </a:defRPr>
       </a:lvl6pPr>
-      <a:lvl7pPr marL="2743200" algn="l" defTabSz="914400" rtl="0" eaLnBrk="1" latinLnBrk="0" hangingPunct="1">
+      <a:lvl7pPr marL="2743200" algn="l" defTabSz="457200" rtl="0" eaLnBrk="1" latinLnBrk="0" hangingPunct="1">
         <a:defRPr sz="1800" kern="1200">
           <a:solidFill>
             <a:schemeClr val="tx1"/>
@@ -3284,7 +3473,7 @@
           <a:cs typeface="+mn-cs"/>
         </a:defRPr>
       </a:lvl7pPr>
-      <a:lvl8pPr marL="3200400" algn="l" defTabSz="914400" rtl="0" eaLnBrk="1" latinLnBrk="0" hangingPunct="1">
+      <a:lvl8pPr marL="3200400" algn="l" defTabSz="457200" rtl="0" eaLnBrk="1" latinLnBrk="0" hangingPunct="1">
         <a:defRPr sz="1800" kern="1200">
           <a:solidFill>
             <a:schemeClr val="tx1"/>
@@ -3294,7 +3483,7 @@
           <a:cs typeface="+mn-cs"/>
         </a:defRPr>
       </a:lvl8pPr>
-      <a:lvl9pPr marL="3657600" algn="l" defTabSz="914400" rtl="0" eaLnBrk="1" latinLnBrk="0" hangingPunct="1">
+      <a:lvl9pPr marL="3657600" algn="l" defTabSz="457200" rtl="0" eaLnBrk="1" latinLnBrk="0" hangingPunct="1">
         <a:defRPr sz="1800" kern="1200">
           <a:solidFill>
             <a:schemeClr val="tx1"/>
@@ -3310,7 +3499,7 @@
 </file>
 
 <file path=ppt/slides/slide1.xml><?xml version="1.0" encoding="utf-8"?>
-<p:sld xmlns:a="http://schemas.openxmlformats.org/drawingml/2006/main" xmlns:r="http://schemas.openxmlformats.org/officeDocument/2006/relationships" xmlns:p="http://schemas.openxmlformats.org/presentationml/2006/main">
+<p:sld xmlns:a="http://schemas.openxmlformats.org/drawingml/2006/main" xmlns:p="http://schemas.openxmlformats.org/presentationml/2006/main" xmlns:r="http://schemas.openxmlformats.org/officeDocument/2006/relationships">
   <p:cSld>
     <p:spTree>
       <p:nvGrpSpPr>
@@ -3318,90 +3507,65 @@
         <p:cNvGrpSpPr/>
         <p:nvPr/>
       </p:nvGrpSpPr>
-      <p:grpSpPr>
-        <a:xfrm>
-          <a:off x="0" y="0"/>
-          <a:ext cx="0" cy="0"/>
-          <a:chOff x="0" y="0"/>
-          <a:chExt cx="0" cy="0"/>
-        </a:xfrm>
-      </p:grpSpPr>
-      <p:sp>
-        <p:nvSpPr>
-          <p:cNvPr id="2" name="Title 1">
-            <a:extLst>
-              <a:ext uri="{FF2B5EF4-FFF2-40B4-BE49-F238E27FC236}">
-                <a16:creationId xmlns:a16="http://schemas.microsoft.com/office/drawing/2014/main" id="{AC304904-1385-9C9B-A573-28E1B04D808E}"/>
-              </a:ext>
-            </a:extLst>
-          </p:cNvPr>
-          <p:cNvSpPr>
-            <a:spLocks noGrp="1"/>
-          </p:cNvSpPr>
-          <p:nvPr>
-            <p:ph type="ctrTitle"/>
-          </p:nvPr>
+      <p:grpSpPr/>
+      <p:sp>
+        <p:nvSpPr>
+          <p:cNvPr id="2" name="Title 1"/>
+          <p:cNvSpPr>
+            <a:spLocks noGrp="1"/>
+          </p:cNvSpPr>
+          <p:nvPr>
+            <p:ph type="title"/>
+          </p:nvPr>
+        </p:nvSpPr>
+        <p:spPr/>
+        <p:txBody>
+          <a:bodyPr/>
+          <a:lstStyle/>
+          <a:p>
+            <a:r>
+              <a:t>Image and Summary</a:t>
+            </a:r>
+          </a:p>
+        </p:txBody>
+      </p:sp>
+      <p:sp>
+        <p:nvSpPr>
+          <p:cNvPr id="3" name="TextBox 2"/>
+          <p:cNvSpPr txBox="1"/>
+          <p:nvPr/>
         </p:nvSpPr>
         <p:spPr>
           <a:xfrm>
-            <a:off x="4608786" y="641515"/>
-            <a:ext cx="2974428" cy="958685"/>
+            <a:off x="731520" y="1463040"/>
+            <a:ext cx="4114800" cy="1371600"/>
           </a:xfrm>
+          <a:prstGeom prst="rect">
+            <a:avLst/>
+          </a:prstGeom>
+          <a:noFill/>
         </p:spPr>
         <p:txBody>
-          <a:bodyPr/>
-          <a:lstStyle/>
-          <a:p>
-            <a:r>
-              <a:rPr lang="en-US" dirty="0" err="1"/>
-              <a:t>Docling</a:t>
-            </a:r>
-            <a:endParaRPr lang="en-US" dirty="0"/>
-          </a:p>
-        </p:txBody>
-      </p:sp>
-      <p:sp>
-        <p:nvSpPr>
-          <p:cNvPr id="3" name="Subtitle 2">
-            <a:extLst>
-              <a:ext uri="{FF2B5EF4-FFF2-40B4-BE49-F238E27FC236}">
-                <a16:creationId xmlns:a16="http://schemas.microsoft.com/office/drawing/2014/main" id="{562AD60F-5036-F05C-AE79-BA885016B401}"/>
-              </a:ext>
-            </a:extLst>
-          </p:cNvPr>
-          <p:cNvSpPr>
-            <a:spLocks noGrp="1"/>
-          </p:cNvSpPr>
-          <p:nvPr>
-            <p:ph type="subTitle" idx="1"/>
-          </p:nvPr>
-        </p:nvSpPr>
-        <p:spPr>
-          <a:xfrm>
-            <a:off x="5286703" y="1920383"/>
-            <a:ext cx="1618593" cy="433934"/>
-          </a:xfrm>
-        </p:spPr>
-        <p:txBody>
-          <a:bodyPr/>
-          <a:lstStyle/>
-          <a:p>
-            <a:r>
-              <a:rPr lang="en-US" dirty="0"/>
-              <a:t>Image test</a:t>
+          <a:bodyPr wrap="none">
+            <a:spAutoFit/>
+          </a:bodyPr>
+          <a:lstStyle/>
+          <a:p>
+            <a:r>
+              <a:t>Compact image fixture</a:t>
+            </a:r>
+          </a:p>
+          <a:p>
+            <a:pPr/>
+            <a:r>
+              <a:t>Used to verify text + image coexistence.</a:t>
             </a:r>
           </a:p>
         </p:txBody>
       </p:sp>
       <p:pic>
         <p:nvPicPr>
-          <p:cNvPr id="5" name="Picture 4">
-            <a:extLst>
-              <a:ext uri="{FF2B5EF4-FFF2-40B4-BE49-F238E27FC236}">
-                <a16:creationId xmlns:a16="http://schemas.microsoft.com/office/drawing/2014/main" id="{C4366B9B-E710-79BE-EA4A-BA9CF98996A6}"/>
-              </a:ext>
-            </a:extLst>
-          </p:cNvPr>
+          <p:cNvPr id="4" name="Picture 3" descr="tiny-red.png"/>
           <p:cNvPicPr>
             <a:picLocks noChangeAspect="1"/>
           </p:cNvPicPr>
@@ -3415,249 +3579,15 @@
         </p:blipFill>
         <p:spPr>
           <a:xfrm>
-            <a:off x="5689599" y="3022600"/>
-            <a:ext cx="812800" cy="812800"/>
+            <a:off x="5120640" y="1645920"/>
+            <a:ext cx="914400" cy="914400"/>
           </a:xfrm>
           <a:prstGeom prst="rect">
             <a:avLst/>
           </a:prstGeom>
         </p:spPr>
       </p:pic>
-      <p:pic>
-        <p:nvPicPr>
-          <p:cNvPr id="6" name="Picture 5" descr="A cartoon duck holding a paper&#10;&#10;AI-generated content may be incorrect.">
-            <a:extLst>
-              <a:ext uri="{FF2B5EF4-FFF2-40B4-BE49-F238E27FC236}">
-                <a16:creationId xmlns:a16="http://schemas.microsoft.com/office/drawing/2014/main" id="{C9B5DA62-3A0F-9035-66C6-3BF76C2DFD8B}"/>
-              </a:ext>
-            </a:extLst>
-          </p:cNvPr>
-          <p:cNvPicPr>
-            <a:picLocks noChangeAspect="1"/>
-          </p:cNvPicPr>
-          <p:nvPr/>
-        </p:nvPicPr>
-        <p:blipFill>
-          <a:blip r:link="rId3"/>
-          <a:stretch>
-            <a:fillRect/>
-          </a:stretch>
-        </p:blipFill>
-        <p:spPr>
-          <a:xfrm>
-            <a:off x="5689599" y="5407188"/>
-            <a:ext cx="809297" cy="809297"/>
-          </a:xfrm>
-          <a:prstGeom prst="rect">
-            <a:avLst/>
-          </a:prstGeom>
-        </p:spPr>
-      </p:pic>
-      <p:sp>
-        <p:nvSpPr>
-          <p:cNvPr id="7" name="Subtitle 2">
-            <a:extLst>
-              <a:ext uri="{FF2B5EF4-FFF2-40B4-BE49-F238E27FC236}">
-                <a16:creationId xmlns:a16="http://schemas.microsoft.com/office/drawing/2014/main" id="{AFB2A747-FFCD-668F-D21A-79290F5F2070}"/>
-              </a:ext>
-            </a:extLst>
-          </p:cNvPr>
-          <p:cNvSpPr txBox="1">
-            <a:spLocks/>
-          </p:cNvSpPr>
-          <p:nvPr/>
-        </p:nvSpPr>
-        <p:spPr>
-          <a:xfrm>
-            <a:off x="4965460" y="4503683"/>
-            <a:ext cx="2647195" cy="433934"/>
-          </a:xfrm>
-          <a:prstGeom prst="rect">
-            <a:avLst/>
-          </a:prstGeom>
-        </p:spPr>
-        <p:txBody>
-          <a:bodyPr vert="horz" lIns="91440" tIns="45720" rIns="91440" bIns="45720" rtlCol="0">
-            <a:normAutofit/>
-          </a:bodyPr>
-          <a:lstStyle>
-            <a:lvl1pPr marL="0" indent="0" algn="ctr" defTabSz="914400" rtl="0" eaLnBrk="1" latinLnBrk="0" hangingPunct="1">
-              <a:lnSpc>
-                <a:spcPct val="90000"/>
-              </a:lnSpc>
-              <a:spcBef>
-                <a:spcPts val="1000"/>
-              </a:spcBef>
-              <a:buFont typeface="Arial" panose="020B0604020202020204" pitchFamily="34" charset="0"/>
-              <a:buNone/>
-              <a:defRPr sz="2400" kern="1200">
-                <a:solidFill>
-                  <a:schemeClr val="tx1"/>
-                </a:solidFill>
-                <a:latin typeface="+mn-lt"/>
-                <a:ea typeface="+mn-ea"/>
-                <a:cs typeface="+mn-cs"/>
-              </a:defRPr>
-            </a:lvl1pPr>
-            <a:lvl2pPr marL="457200" indent="0" algn="ctr" defTabSz="914400" rtl="0" eaLnBrk="1" latinLnBrk="0" hangingPunct="1">
-              <a:lnSpc>
-                <a:spcPct val="90000"/>
-              </a:lnSpc>
-              <a:spcBef>
-                <a:spcPts val="500"/>
-              </a:spcBef>
-              <a:buFont typeface="Arial" panose="020B0604020202020204" pitchFamily="34" charset="0"/>
-              <a:buNone/>
-              <a:defRPr sz="2000" kern="1200">
-                <a:solidFill>
-                  <a:schemeClr val="tx1"/>
-                </a:solidFill>
-                <a:latin typeface="+mn-lt"/>
-                <a:ea typeface="+mn-ea"/>
-                <a:cs typeface="+mn-cs"/>
-              </a:defRPr>
-            </a:lvl2pPr>
-            <a:lvl3pPr marL="914400" indent="0" algn="ctr" defTabSz="914400" rtl="0" eaLnBrk="1" latinLnBrk="0" hangingPunct="1">
-              <a:lnSpc>
-                <a:spcPct val="90000"/>
-              </a:lnSpc>
-              <a:spcBef>
-                <a:spcPts val="500"/>
-              </a:spcBef>
-              <a:buFont typeface="Arial" panose="020B0604020202020204" pitchFamily="34" charset="0"/>
-              <a:buNone/>
-              <a:defRPr sz="1800" kern="1200">
-                <a:solidFill>
-                  <a:schemeClr val="tx1"/>
-                </a:solidFill>
-                <a:latin typeface="+mn-lt"/>
-                <a:ea typeface="+mn-ea"/>
-                <a:cs typeface="+mn-cs"/>
-              </a:defRPr>
-            </a:lvl3pPr>
-            <a:lvl4pPr marL="1371600" indent="0" algn="ctr" defTabSz="914400" rtl="0" eaLnBrk="1" latinLnBrk="0" hangingPunct="1">
-              <a:lnSpc>
-                <a:spcPct val="90000"/>
-              </a:lnSpc>
-              <a:spcBef>
-                <a:spcPts val="500"/>
-              </a:spcBef>
-              <a:buFont typeface="Arial" panose="020B0604020202020204" pitchFamily="34" charset="0"/>
-              <a:buNone/>
-              <a:defRPr sz="1600" kern="1200">
-                <a:solidFill>
-                  <a:schemeClr val="tx1"/>
-                </a:solidFill>
-                <a:latin typeface="+mn-lt"/>
-                <a:ea typeface="+mn-ea"/>
-                <a:cs typeface="+mn-cs"/>
-              </a:defRPr>
-            </a:lvl4pPr>
-            <a:lvl5pPr marL="1828800" indent="0" algn="ctr" defTabSz="914400" rtl="0" eaLnBrk="1" latinLnBrk="0" hangingPunct="1">
-              <a:lnSpc>
-                <a:spcPct val="90000"/>
-              </a:lnSpc>
-              <a:spcBef>
-                <a:spcPts val="500"/>
-              </a:spcBef>
-              <a:buFont typeface="Arial" panose="020B0604020202020204" pitchFamily="34" charset="0"/>
-              <a:buNone/>
-              <a:defRPr sz="1600" kern="1200">
-                <a:solidFill>
-                  <a:schemeClr val="tx1"/>
-                </a:solidFill>
-                <a:latin typeface="+mn-lt"/>
-                <a:ea typeface="+mn-ea"/>
-                <a:cs typeface="+mn-cs"/>
-              </a:defRPr>
-            </a:lvl5pPr>
-            <a:lvl6pPr marL="2286000" indent="0" algn="ctr" defTabSz="914400" rtl="0" eaLnBrk="1" latinLnBrk="0" hangingPunct="1">
-              <a:lnSpc>
-                <a:spcPct val="90000"/>
-              </a:lnSpc>
-              <a:spcBef>
-                <a:spcPts val="500"/>
-              </a:spcBef>
-              <a:buFont typeface="Arial" panose="020B0604020202020204" pitchFamily="34" charset="0"/>
-              <a:buNone/>
-              <a:defRPr sz="1600" kern="1200">
-                <a:solidFill>
-                  <a:schemeClr val="tx1"/>
-                </a:solidFill>
-                <a:latin typeface="+mn-lt"/>
-                <a:ea typeface="+mn-ea"/>
-                <a:cs typeface="+mn-cs"/>
-              </a:defRPr>
-            </a:lvl6pPr>
-            <a:lvl7pPr marL="2743200" indent="0" algn="ctr" defTabSz="914400" rtl="0" eaLnBrk="1" latinLnBrk="0" hangingPunct="1">
-              <a:lnSpc>
-                <a:spcPct val="90000"/>
-              </a:lnSpc>
-              <a:spcBef>
-                <a:spcPts val="500"/>
-              </a:spcBef>
-              <a:buFont typeface="Arial" panose="020B0604020202020204" pitchFamily="34" charset="0"/>
-              <a:buNone/>
-              <a:defRPr sz="1600" kern="1200">
-                <a:solidFill>
-                  <a:schemeClr val="tx1"/>
-                </a:solidFill>
-                <a:latin typeface="+mn-lt"/>
-                <a:ea typeface="+mn-ea"/>
-                <a:cs typeface="+mn-cs"/>
-              </a:defRPr>
-            </a:lvl7pPr>
-            <a:lvl8pPr marL="3200400" indent="0" algn="ctr" defTabSz="914400" rtl="0" eaLnBrk="1" latinLnBrk="0" hangingPunct="1">
-              <a:lnSpc>
-                <a:spcPct val="90000"/>
-              </a:lnSpc>
-              <a:spcBef>
-                <a:spcPts val="500"/>
-              </a:spcBef>
-              <a:buFont typeface="Arial" panose="020B0604020202020204" pitchFamily="34" charset="0"/>
-              <a:buNone/>
-              <a:defRPr sz="1600" kern="1200">
-                <a:solidFill>
-                  <a:schemeClr val="tx1"/>
-                </a:solidFill>
-                <a:latin typeface="+mn-lt"/>
-                <a:ea typeface="+mn-ea"/>
-                <a:cs typeface="+mn-cs"/>
-              </a:defRPr>
-            </a:lvl8pPr>
-            <a:lvl9pPr marL="3657600" indent="0" algn="ctr" defTabSz="914400" rtl="0" eaLnBrk="1" latinLnBrk="0" hangingPunct="1">
-              <a:lnSpc>
-                <a:spcPct val="90000"/>
-              </a:lnSpc>
-              <a:spcBef>
-                <a:spcPts val="500"/>
-              </a:spcBef>
-              <a:buFont typeface="Arial" panose="020B0604020202020204" pitchFamily="34" charset="0"/>
-              <a:buNone/>
-              <a:defRPr sz="1600" kern="1200">
-                <a:solidFill>
-                  <a:schemeClr val="tx1"/>
-                </a:solidFill>
-                <a:latin typeface="+mn-lt"/>
-                <a:ea typeface="+mn-ea"/>
-                <a:cs typeface="+mn-cs"/>
-              </a:defRPr>
-            </a:lvl9pPr>
-          </a:lstStyle>
-          <a:p>
-            <a:r>
-              <a:rPr lang="en-US" dirty="0"/>
-              <a:t>Image linked to file</a:t>
-            </a:r>
-          </a:p>
-        </p:txBody>
-      </p:sp>
     </p:spTree>
-    <p:extLst>
-      <p:ext uri="{BB962C8B-B14F-4D97-AF65-F5344CB8AC3E}">
-        <p14:creationId xmlns:p14="http://schemas.microsoft.com/office/powerpoint/2010/main" val="785624770"/>
-      </p:ext>
-    </p:extLst>
   </p:cSld>
   <p:clrMapOvr>
     <a:masterClrMapping/>
@@ -3676,44 +3606,44 @@
         <a:sysClr val="window" lastClr="FFFFFF"/>
       </a:lt1>
       <a:dk2>
-        <a:srgbClr val="0E2841"/>
+        <a:srgbClr val="1F497D"/>
       </a:dk2>
       <a:lt2>
-        <a:srgbClr val="E8E8E8"/>
+        <a:srgbClr val="EEECE1"/>
       </a:lt2>
       <a:accent1>
-        <a:srgbClr val="156082"/>
+        <a:srgbClr val="4F81BD"/>
       </a:accent1>
       <a:accent2>
-        <a:srgbClr val="E97132"/>
+        <a:srgbClr val="C0504D"/>
       </a:accent2>
       <a:accent3>
-        <a:srgbClr val="196B24"/>
+        <a:srgbClr val="9BBB59"/>
       </a:accent3>
       <a:accent4>
-        <a:srgbClr val="0F9ED5"/>
+        <a:srgbClr val="8064A2"/>
       </a:accent4>
       <a:accent5>
-        <a:srgbClr val="A02B93"/>
+        <a:srgbClr val="4BACC6"/>
       </a:accent5>
       <a:accent6>
-        <a:srgbClr val="4EA72E"/>
+        <a:srgbClr val="F79646"/>
       </a:accent6>
       <a:hlink>
-        <a:srgbClr val="467886"/>
+        <a:srgbClr val="0000FF"/>
       </a:hlink>
       <a:folHlink>
-        <a:srgbClr val="96607D"/>
+        <a:srgbClr val="800080"/>
       </a:folHlink>
     </a:clrScheme>
     <a:fontScheme name="Office">
       <a:majorFont>
-        <a:latin typeface="Aptos Display" panose="02110004020202020204"/>
+        <a:latin typeface="Calibri"/>
         <a:ea typeface=""/>
         <a:cs typeface=""/>
-        <a:font script="Jpan" typeface="游ゴシック Light"/>
+        <a:font script="Jpan" typeface="ＭＳ Ｐゴシック"/>
         <a:font script="Hang" typeface="맑은 고딕"/>
-        <a:font script="Hans" typeface="等线 Light"/>
+        <a:font script="Hans" typeface="宋体"/>
         <a:font script="Hant" typeface="新細明體"/>
         <a:font script="Arab" typeface="Times New Roman"/>
         <a:font script="Hebr" typeface="Times New Roman"/>
@@ -3741,31 +3671,14 @@
         <a:font script="Viet" typeface="Times New Roman"/>
         <a:font script="Uigh" typeface="Microsoft Uighur"/>
         <a:font script="Geor" typeface="Sylfaen"/>
-        <a:font script="Armn" typeface="Arial"/>
-        <a:font script="Bugi" typeface="Leelawadee UI"/>
-        <a:font script="Bopo" typeface="Microsoft JhengHei"/>
-        <a:font script="Java" typeface="Javanese Text"/>
-        <a:font script="Lisu" typeface="Segoe UI"/>
-        <a:font script="Mymr" typeface="Myanmar Text"/>
-        <a:font script="Nkoo" typeface="Ebrima"/>
-        <a:font script="Olck" typeface="Nirmala UI"/>
-        <a:font script="Osma" typeface="Ebrima"/>
-        <a:font script="Phag" typeface="Phagspa"/>
-        <a:font script="Syrn" typeface="Estrangelo Edessa"/>
-        <a:font script="Syrj" typeface="Estrangelo Edessa"/>
-        <a:font script="Syre" typeface="Estrangelo Edessa"/>
-        <a:font script="Sora" typeface="Nirmala UI"/>
-        <a:font script="Tale" typeface="Microsoft Tai Le"/>
-        <a:font script="Talu" typeface="Microsoft New Tai Lue"/>
-        <a:font script="Tfng" typeface="Ebrima"/>
       </a:majorFont>
       <a:minorFont>
-        <a:latin typeface="Aptos" panose="02110004020202020204"/>
+        <a:latin typeface="Calibri"/>
         <a:ea typeface=""/>
         <a:cs typeface=""/>
-        <a:font script="Jpan" typeface="游ゴシック"/>
+        <a:font script="Jpan" typeface="ＭＳ Ｐゴシック"/>
         <a:font script="Hang" typeface="맑은 고딕"/>
-        <a:font script="Hans" typeface="等线"/>
+        <a:font script="Hans" typeface="宋体"/>
         <a:font script="Hant" typeface="新細明體"/>
         <a:font script="Arab" typeface="Arial"/>
         <a:font script="Hebr" typeface="Arial"/>
@@ -3793,23 +3706,6 @@
         <a:font script="Viet" typeface="Arial"/>
         <a:font script="Uigh" typeface="Microsoft Uighur"/>
         <a:font script="Geor" typeface="Sylfaen"/>
-        <a:font script="Armn" typeface="Arial"/>
-        <a:font script="Bugi" typeface="Leelawadee UI"/>
-        <a:font script="Bopo" typeface="Microsoft JhengHei"/>
-        <a:font script="Java" typeface="Javanese Text"/>
-        <a:font script="Lisu" typeface="Segoe UI"/>
-        <a:font script="Mymr" typeface="Myanmar Text"/>
-        <a:font script="Nkoo" typeface="Ebrima"/>
-        <a:font script="Olck" typeface="Nirmala UI"/>
-        <a:font script="Osma" typeface="Ebrima"/>
-        <a:font script="Phag" typeface="Phagspa"/>
-        <a:font script="Syrn" typeface="Estrangelo Edessa"/>
-        <a:font script="Syrj" typeface="Estrangelo Edessa"/>
-        <a:font script="Syre" typeface="Estrangelo Edessa"/>
-        <a:font script="Sora" typeface="Nirmala UI"/>
-        <a:font script="Tale" typeface="Microsoft Tai Le"/>
-        <a:font script="Talu" typeface="Microsoft New Tai Lue"/>
-        <a:font script="Tfng" typeface="Ebrima"/>
       </a:minorFont>
     </a:fontScheme>
     <a:fmtScheme name="Office">
@@ -3821,136 +3717,180 @@
           <a:gsLst>
             <a:gs pos="0">
               <a:schemeClr val="phClr">
-                <a:lumMod val="110000"/>
-                <a:satMod val="105000"/>
-                <a:tint val="67000"/>
+                <a:tint val="50000"/>
+                <a:satMod val="300000"/>
               </a:schemeClr>
             </a:gs>
-            <a:gs pos="50000">
+            <a:gs pos="35000">
               <a:schemeClr val="phClr">
-                <a:lumMod val="105000"/>
-                <a:satMod val="103000"/>
-                <a:tint val="73000"/>
+                <a:tint val="37000"/>
+                <a:satMod val="300000"/>
               </a:schemeClr>
             </a:gs>
             <a:gs pos="100000">
               <a:schemeClr val="phClr">
-                <a:lumMod val="105000"/>
-                <a:satMod val="109000"/>
-                <a:tint val="81000"/>
+                <a:tint val="15000"/>
+                <a:satMod val="350000"/>
               </a:schemeClr>
             </a:gs>
           </a:gsLst>
-          <a:lin ang="5400000" scaled="0"/>
+          <a:lin ang="16200000" scaled="1"/>
         </a:gradFill>
         <a:gradFill rotWithShape="1">
           <a:gsLst>
             <a:gs pos="0">
               <a:schemeClr val="phClr">
-                <a:satMod val="103000"/>
-                <a:lumMod val="102000"/>
-                <a:tint val="94000"/>
-              </a:schemeClr>
-            </a:gs>
-            <a:gs pos="50000">
-              <a:schemeClr val="phClr">
-                <a:satMod val="110000"/>
-                <a:lumMod val="100000"/>
+                <a:tint val="100000"/>
                 <a:shade val="100000"/>
+                <a:satMod val="130000"/>
               </a:schemeClr>
             </a:gs>
             <a:gs pos="100000">
               <a:schemeClr val="phClr">
-                <a:lumMod val="99000"/>
-                <a:satMod val="120000"/>
-                <a:shade val="78000"/>
+                <a:tint val="50000"/>
+                <a:shade val="100000"/>
+                <a:satMod val="350000"/>
               </a:schemeClr>
             </a:gs>
           </a:gsLst>
-          <a:lin ang="5400000" scaled="0"/>
+          <a:lin ang="16200000" scaled="0"/>
         </a:gradFill>
       </a:fillStyleLst>
       <a:lnStyleLst>
-        <a:ln w="12700" cap="flat" cmpd="sng" algn="ctr">
+        <a:ln w="9525" cap="flat" cmpd="sng" algn="ctr">
           <a:solidFill>
-            <a:schemeClr val="phClr"/>
+            <a:schemeClr val="phClr">
+              <a:shade val="95000"/>
+              <a:satMod val="105000"/>
+            </a:schemeClr>
           </a:solidFill>
           <a:prstDash val="solid"/>
-          <a:miter lim="800000"/>
-        </a:ln>
-        <a:ln w="19050" cap="flat" cmpd="sng" algn="ctr">
-          <a:solidFill>
-            <a:schemeClr val="phClr"/>
-          </a:solidFill>
-          <a:prstDash val="solid"/>
-          <a:miter lim="800000"/>
         </a:ln>
         <a:ln w="25400" cap="flat" cmpd="sng" algn="ctr">
           <a:solidFill>
             <a:schemeClr val="phClr"/>
           </a:solidFill>
           <a:prstDash val="solid"/>
-          <a:miter lim="800000"/>
+        </a:ln>
+        <a:ln w="38100" cap="flat" cmpd="sng" algn="ctr">
+          <a:solidFill>
+            <a:schemeClr val="phClr"/>
+          </a:solidFill>
+          <a:prstDash val="solid"/>
         </a:ln>
       </a:lnStyleLst>
       <a:effectStyleLst>
         <a:effectStyle>
-          <a:effectLst/>
-        </a:effectStyle>
-        <a:effectStyle>
-          <a:effectLst/>
+          <a:effectLst>
+            <a:outerShdw blurRad="40000" dist="20000" dir="5400000" rotWithShape="0">
+              <a:srgbClr val="000000">
+                <a:alpha val="38000"/>
+              </a:srgbClr>
+            </a:outerShdw>
+          </a:effectLst>
         </a:effectStyle>
         <a:effectStyle>
           <a:effectLst>
-            <a:outerShdw blurRad="57150" dist="19050" dir="5400000" algn="ctr" rotWithShape="0">
+            <a:outerShdw blurRad="40000" dist="23000" dir="5400000" rotWithShape="0">
               <a:srgbClr val="000000">
-                <a:alpha val="63000"/>
+                <a:alpha val="35000"/>
               </a:srgbClr>
             </a:outerShdw>
           </a:effectLst>
+        </a:effectStyle>
+        <a:effectStyle>
+          <a:effectLst>
+            <a:outerShdw blurRad="40000" dist="23000" dir="5400000" rotWithShape="0">
+              <a:srgbClr val="000000">
+                <a:alpha val="35000"/>
+              </a:srgbClr>
+            </a:outerShdw>
+          </a:effectLst>
+          <a:scene3d>
+            <a:camera prst="orthographicFront">
+              <a:rot lat="0" lon="0" rev="0"/>
+            </a:camera>
+            <a:lightRig rig="threePt" dir="t">
+              <a:rot lat="0" lon="0" rev="1200000"/>
+            </a:lightRig>
+          </a:scene3d>
+          <a:sp3d>
+            <a:bevelT w="63500" h="25400"/>
+          </a:sp3d>
         </a:effectStyle>
       </a:effectStyleLst>
       <a:bgFillStyleLst>
         <a:solidFill>
           <a:schemeClr val="phClr"/>
         </a:solidFill>
-        <a:solidFill>
-          <a:schemeClr val="phClr">
-            <a:tint val="95000"/>
-            <a:satMod val="170000"/>
-          </a:schemeClr>
-        </a:solidFill>
         <a:gradFill rotWithShape="1">
           <a:gsLst>
             <a:gs pos="0">
               <a:schemeClr val="phClr">
-                <a:tint val="93000"/>
-                <a:satMod val="150000"/>
-                <a:shade val="98000"/>
-                <a:lumMod val="102000"/>
+                <a:tint val="40000"/>
+                <a:satMod val="350000"/>
               </a:schemeClr>
             </a:gs>
-            <a:gs pos="50000">
+            <a:gs pos="40000">
               <a:schemeClr val="phClr">
-                <a:tint val="98000"/>
-                <a:satMod val="130000"/>
-                <a:shade val="90000"/>
-                <a:lumMod val="103000"/>
+                <a:tint val="45000"/>
+                <a:shade val="99000"/>
+                <a:satMod val="350000"/>
               </a:schemeClr>
             </a:gs>
             <a:gs pos="100000">
               <a:schemeClr val="phClr">
-                <a:shade val="63000"/>
-                <a:satMod val="120000"/>
+                <a:shade val="20000"/>
+                <a:satMod val="255000"/>
               </a:schemeClr>
             </a:gs>
           </a:gsLst>
-          <a:lin ang="5400000" scaled="0"/>
+          <a:path path="circle">
+            <a:fillToRect l="50000" t="-80000" r="50000" b="180000"/>
+          </a:path>
+        </a:gradFill>
+        <a:gradFill rotWithShape="1">
+          <a:gsLst>
+            <a:gs pos="0">
+              <a:schemeClr val="phClr">
+                <a:tint val="80000"/>
+                <a:satMod val="300000"/>
+              </a:schemeClr>
+            </a:gs>
+            <a:gs pos="100000">
+              <a:schemeClr val="phClr">
+                <a:shade val="30000"/>
+                <a:satMod val="200000"/>
+              </a:schemeClr>
+            </a:gs>
+          </a:gsLst>
+          <a:path path="circle">
+            <a:fillToRect l="50000" t="50000" r="50000" b="50000"/>
+          </a:path>
         </a:gradFill>
       </a:bgFillStyleLst>
     </a:fmtScheme>
   </a:themeElements>
   <a:objectDefaults>
+    <a:spDef>
+      <a:spPr/>
+      <a:bodyPr/>
+      <a:lstStyle/>
+      <a:style>
+        <a:lnRef idx="1">
+          <a:schemeClr val="accent1"/>
+        </a:lnRef>
+        <a:fillRef idx="3">
+          <a:schemeClr val="accent1"/>
+        </a:fillRef>
+        <a:effectRef idx="2">
+          <a:schemeClr val="accent1"/>
+        </a:effectRef>
+        <a:fontRef idx="minor">
+          <a:schemeClr val="lt1"/>
+        </a:fontRef>
+      </a:style>
+    </a:spDef>
     <a:lnDef>
       <a:spPr/>
       <a:bodyPr/>
@@ -3972,10 +3912,325 @@
     </a:lnDef>
   </a:objectDefaults>
   <a:extraClrSchemeLst/>
-  <a:extLst>
-    <a:ext uri="{05A4C25C-085E-4340-85A3-A5531E510DB2}">
-      <thm15:themeFamily xmlns:thm15="http://schemas.microsoft.com/office/thememl/2012/main" name="Office Theme" id="{2E142A2C-CD16-42D6-873A-C26D2A0506FA}" vid="{1BDDFF52-6CD6-40A5-AB3C-68EB2F1E4D0A}"/>
-    </a:ext>
-  </a:extLst>
+</a:theme>
+</file>
+
+<file path=ppt/theme/theme2.xml><?xml version="1.0" encoding="utf-8"?>
+<a:theme xmlns:a="http://schemas.openxmlformats.org/drawingml/2006/main" name="Office Theme">
+  <a:themeElements>
+    <a:clrScheme name="Office">
+      <a:dk1>
+        <a:sysClr val="windowText" lastClr="000000"/>
+      </a:dk1>
+      <a:lt1>
+        <a:sysClr val="window" lastClr="FFFFFF"/>
+      </a:lt1>
+      <a:dk2>
+        <a:srgbClr val="1F497D"/>
+      </a:dk2>
+      <a:lt2>
+        <a:srgbClr val="EEECE1"/>
+      </a:lt2>
+      <a:accent1>
+        <a:srgbClr val="4F81BD"/>
+      </a:accent1>
+      <a:accent2>
+        <a:srgbClr val="C0504D"/>
+      </a:accent2>
+      <a:accent3>
+        <a:srgbClr val="9BBB59"/>
+      </a:accent3>
+      <a:accent4>
+        <a:srgbClr val="8064A2"/>
+      </a:accent4>
+      <a:accent5>
+        <a:srgbClr val="4BACC6"/>
+      </a:accent5>
+      <a:accent6>
+        <a:srgbClr val="F79646"/>
+      </a:accent6>
+      <a:hlink>
+        <a:srgbClr val="0000FF"/>
+      </a:hlink>
+      <a:folHlink>
+        <a:srgbClr val="800080"/>
+      </a:folHlink>
+    </a:clrScheme>
+    <a:fontScheme name="Office">
+      <a:majorFont>
+        <a:latin typeface="Calibri"/>
+        <a:ea typeface=""/>
+        <a:cs typeface=""/>
+        <a:font script="Jpan" typeface="ＭＳ Ｐゴシック"/>
+        <a:font script="Hang" typeface="맑은 고딕"/>
+        <a:font script="Hans" typeface="宋体"/>
+        <a:font script="Hant" typeface="新細明體"/>
+        <a:font script="Arab" typeface="Times New Roman"/>
+        <a:font script="Hebr" typeface="Times New Roman"/>
+        <a:font script="Thai" typeface="Angsana New"/>
+        <a:font script="Ethi" typeface="Nyala"/>
+        <a:font script="Beng" typeface="Vrinda"/>
+        <a:font script="Gujr" typeface="Shruti"/>
+        <a:font script="Khmr" typeface="MoolBoran"/>
+        <a:font script="Knda" typeface="Tunga"/>
+        <a:font script="Guru" typeface="Raavi"/>
+        <a:font script="Cans" typeface="Euphemia"/>
+        <a:font script="Cher" typeface="Plantagenet Cherokee"/>
+        <a:font script="Yiii" typeface="Microsoft Yi Baiti"/>
+        <a:font script="Tibt" typeface="Microsoft Himalaya"/>
+        <a:font script="Thaa" typeface="MV Boli"/>
+        <a:font script="Deva" typeface="Mangal"/>
+        <a:font script="Telu" typeface="Gautami"/>
+        <a:font script="Taml" typeface="Latha"/>
+        <a:font script="Syrc" typeface="Estrangelo Edessa"/>
+        <a:font script="Orya" typeface="Kalinga"/>
+        <a:font script="Mlym" typeface="Kartika"/>
+        <a:font script="Laoo" typeface="DokChampa"/>
+        <a:font script="Sinh" typeface="Iskoola Pota"/>
+        <a:font script="Mong" typeface="Mongolian Baiti"/>
+        <a:font script="Viet" typeface="Times New Roman"/>
+        <a:font script="Uigh" typeface="Microsoft Uighur"/>
+        <a:font script="Geor" typeface="Sylfaen"/>
+      </a:majorFont>
+      <a:minorFont>
+        <a:latin typeface="Calibri"/>
+        <a:ea typeface=""/>
+        <a:cs typeface=""/>
+        <a:font script="Jpan" typeface="ＭＳ Ｐゴシック"/>
+        <a:font script="Hang" typeface="맑은 고딕"/>
+        <a:font script="Hans" typeface="宋体"/>
+        <a:font script="Hant" typeface="新細明體"/>
+        <a:font script="Arab" typeface="Arial"/>
+        <a:font script="Hebr" typeface="Arial"/>
+        <a:font script="Thai" typeface="Cordia New"/>
+        <a:font script="Ethi" typeface="Nyala"/>
+        <a:font script="Beng" typeface="Vrinda"/>
+        <a:font script="Gujr" typeface="Shruti"/>
+        <a:font script="Khmr" typeface="DaunPenh"/>
+        <a:font script="Knda" typeface="Tunga"/>
+        <a:font script="Guru" typeface="Raavi"/>
+        <a:font script="Cans" typeface="Euphemia"/>
+        <a:font script="Cher" typeface="Plantagenet Cherokee"/>
+        <a:font script="Yiii" typeface="Microsoft Yi Baiti"/>
+        <a:font script="Tibt" typeface="Microsoft Himalaya"/>
+        <a:font script="Thaa" typeface="MV Boli"/>
+        <a:font script="Deva" typeface="Mangal"/>
+        <a:font script="Telu" typeface="Gautami"/>
+        <a:font script="Taml" typeface="Latha"/>
+        <a:font script="Syrc" typeface="Estrangelo Edessa"/>
+        <a:font script="Orya" typeface="Kalinga"/>
+        <a:font script="Mlym" typeface="Kartika"/>
+        <a:font script="Laoo" typeface="DokChampa"/>
+        <a:font script="Sinh" typeface="Iskoola Pota"/>
+        <a:font script="Mong" typeface="Mongolian Baiti"/>
+        <a:font script="Viet" typeface="Arial"/>
+        <a:font script="Uigh" typeface="Microsoft Uighur"/>
+        <a:font script="Geor" typeface="Sylfaen"/>
+      </a:minorFont>
+    </a:fontScheme>
+    <a:fmtScheme name="Office">
+      <a:fillStyleLst>
+        <a:solidFill>
+          <a:schemeClr val="phClr"/>
+        </a:solidFill>
+        <a:gradFill rotWithShape="1">
+          <a:gsLst>
+            <a:gs pos="0">
+              <a:schemeClr val="phClr">
+                <a:tint val="50000"/>
+                <a:satMod val="300000"/>
+              </a:schemeClr>
+            </a:gs>
+            <a:gs pos="35000">
+              <a:schemeClr val="phClr">
+                <a:tint val="37000"/>
+                <a:satMod val="300000"/>
+              </a:schemeClr>
+            </a:gs>
+            <a:gs pos="100000">
+              <a:schemeClr val="phClr">
+                <a:tint val="15000"/>
+                <a:satMod val="350000"/>
+              </a:schemeClr>
+            </a:gs>
+          </a:gsLst>
+          <a:lin ang="16200000" scaled="1"/>
+        </a:gradFill>
+        <a:gradFill rotWithShape="1">
+          <a:gsLst>
+            <a:gs pos="0">
+              <a:schemeClr val="phClr">
+                <a:tint val="100000"/>
+                <a:shade val="100000"/>
+                <a:satMod val="130000"/>
+              </a:schemeClr>
+            </a:gs>
+            <a:gs pos="100000">
+              <a:schemeClr val="phClr">
+                <a:tint val="50000"/>
+                <a:shade val="100000"/>
+                <a:satMod val="350000"/>
+              </a:schemeClr>
+            </a:gs>
+          </a:gsLst>
+          <a:lin ang="16200000" scaled="0"/>
+        </a:gradFill>
+      </a:fillStyleLst>
+      <a:lnStyleLst>
+        <a:ln w="9525" cap="flat" cmpd="sng" algn="ctr">
+          <a:solidFill>
+            <a:schemeClr val="phClr">
+              <a:shade val="95000"/>
+              <a:satMod val="105000"/>
+            </a:schemeClr>
+          </a:solidFill>
+          <a:prstDash val="solid"/>
+        </a:ln>
+        <a:ln w="25400" cap="flat" cmpd="sng" algn="ctr">
+          <a:solidFill>
+            <a:schemeClr val="phClr"/>
+          </a:solidFill>
+          <a:prstDash val="solid"/>
+        </a:ln>
+        <a:ln w="38100" cap="flat" cmpd="sng" algn="ctr">
+          <a:solidFill>
+            <a:schemeClr val="phClr"/>
+          </a:solidFill>
+          <a:prstDash val="solid"/>
+        </a:ln>
+      </a:lnStyleLst>
+      <a:effectStyleLst>
+        <a:effectStyle>
+          <a:effectLst>
+            <a:outerShdw blurRad="40000" dist="20000" dir="5400000" rotWithShape="0">
+              <a:srgbClr val="000000">
+                <a:alpha val="38000"/>
+              </a:srgbClr>
+            </a:outerShdw>
+          </a:effectLst>
+        </a:effectStyle>
+        <a:effectStyle>
+          <a:effectLst>
+            <a:outerShdw blurRad="40000" dist="23000" dir="5400000" rotWithShape="0">
+              <a:srgbClr val="000000">
+                <a:alpha val="35000"/>
+              </a:srgbClr>
+            </a:outerShdw>
+          </a:effectLst>
+        </a:effectStyle>
+        <a:effectStyle>
+          <a:effectLst>
+            <a:outerShdw blurRad="40000" dist="23000" dir="5400000" rotWithShape="0">
+              <a:srgbClr val="000000">
+                <a:alpha val="35000"/>
+              </a:srgbClr>
+            </a:outerShdw>
+          </a:effectLst>
+          <a:scene3d>
+            <a:camera prst="orthographicFront">
+              <a:rot lat="0" lon="0" rev="0"/>
+            </a:camera>
+            <a:lightRig rig="threePt" dir="t">
+              <a:rot lat="0" lon="0" rev="1200000"/>
+            </a:lightRig>
+          </a:scene3d>
+          <a:sp3d>
+            <a:bevelT w="63500" h="25400"/>
+          </a:sp3d>
+        </a:effectStyle>
+      </a:effectStyleLst>
+      <a:bgFillStyleLst>
+        <a:solidFill>
+          <a:schemeClr val="phClr"/>
+        </a:solidFill>
+        <a:gradFill rotWithShape="1">
+          <a:gsLst>
+            <a:gs pos="0">
+              <a:schemeClr val="phClr">
+                <a:tint val="40000"/>
+                <a:satMod val="350000"/>
+              </a:schemeClr>
+            </a:gs>
+            <a:gs pos="40000">
+              <a:schemeClr val="phClr">
+                <a:tint val="45000"/>
+                <a:shade val="99000"/>
+                <a:satMod val="350000"/>
+              </a:schemeClr>
+            </a:gs>
+            <a:gs pos="100000">
+              <a:schemeClr val="phClr">
+                <a:shade val="20000"/>
+                <a:satMod val="255000"/>
+              </a:schemeClr>
+            </a:gs>
+          </a:gsLst>
+          <a:path path="circle">
+            <a:fillToRect l="50000" t="-80000" r="50000" b="180000"/>
+          </a:path>
+        </a:gradFill>
+        <a:gradFill rotWithShape="1">
+          <a:gsLst>
+            <a:gs pos="0">
+              <a:schemeClr val="phClr">
+                <a:tint val="80000"/>
+                <a:satMod val="300000"/>
+              </a:schemeClr>
+            </a:gs>
+            <a:gs pos="100000">
+              <a:schemeClr val="phClr">
+                <a:shade val="30000"/>
+                <a:satMod val="200000"/>
+              </a:schemeClr>
+            </a:gs>
+          </a:gsLst>
+          <a:path path="circle">
+            <a:fillToRect l="50000" t="50000" r="50000" b="50000"/>
+          </a:path>
+        </a:gradFill>
+      </a:bgFillStyleLst>
+    </a:fmtScheme>
+  </a:themeElements>
+  <a:objectDefaults>
+    <a:spDef>
+      <a:spPr/>
+      <a:bodyPr/>
+      <a:lstStyle/>
+      <a:style>
+        <a:lnRef idx="1">
+          <a:schemeClr val="accent1"/>
+        </a:lnRef>
+        <a:fillRef idx="3">
+          <a:schemeClr val="accent1"/>
+        </a:fillRef>
+        <a:effectRef idx="2">
+          <a:schemeClr val="accent1"/>
+        </a:effectRef>
+        <a:fontRef idx="minor">
+          <a:schemeClr val="lt1"/>
+        </a:fontRef>
+      </a:style>
+    </a:spDef>
+    <a:lnDef>
+      <a:spPr/>
+      <a:bodyPr/>
+      <a:lstStyle/>
+      <a:style>
+        <a:lnRef idx="2">
+          <a:schemeClr val="accent1"/>
+        </a:lnRef>
+        <a:fillRef idx="0">
+          <a:schemeClr val="accent1"/>
+        </a:fillRef>
+        <a:effectRef idx="1">
+          <a:schemeClr val="accent1"/>
+        </a:effectRef>
+        <a:fontRef idx="minor">
+          <a:schemeClr val="tx1"/>
+        </a:fontRef>
+      </a:style>
+    </a:lnDef>
+  </a:objectDefaults>
+  <a:extraClrSchemeLst/>
 </a:theme>
 </file>
</xml_diff>